<commit_message>
feat: Add demo video script for HackHazards '26 submission
</commit_message>
<xml_diff>
--- a/presentation.pptx
+++ b/presentation.pptx
@@ -3089,7 +3089,7 @@
     <p:bg>
       <p:bgPr>
         <a:solidFill>
-          <a:srgbClr val="F8FAFC"/>
+          <a:srgbClr val="FAFBFC"/>
         </a:solidFill>
         <a:effectLst/>
       </p:bgPr>
@@ -3103,25 +3103,23 @@
       <p:grpSpPr/>
       <p:sp>
         <p:nvSpPr>
-          <p:cNvPr id="2" name="Oval 1"/>
+          <p:cNvPr id="2" name="Rectangle 1"/>
           <p:cNvSpPr/>
           <p:nvPr/>
         </p:nvSpPr>
         <p:spPr>
           <a:xfrm>
-            <a:off x="6858000" y="-1371600"/>
-            <a:ext cx="7315200" cy="7315200"/>
-          </a:xfrm>
-          <a:prstGeom prst="ellipse">
+            <a:off x="8595360" y="0"/>
+            <a:ext cx="3657600" cy="6858000"/>
+          </a:xfrm>
+          <a:prstGeom prst="rect">
             <a:avLst/>
           </a:prstGeom>
           <a:solidFill>
-            <a:srgbClr val="F1F5F9"/>
+            <a:srgbClr val="F0FDF4"/>
           </a:solidFill>
-          <a:ln w="12700">
-            <a:solidFill>
-              <a:srgbClr val="E2E8F0"/>
-            </a:solidFill>
+          <a:ln>
+            <a:noFill/>
           </a:ln>
         </p:spPr>
         <p:style>
@@ -3148,93 +3146,14 @@
       </p:sp>
       <p:sp>
         <p:nvSpPr>
-          <p:cNvPr id="3" name="TextBox 2"/>
-          <p:cNvSpPr txBox="1"/>
-          <p:nvPr/>
-        </p:nvSpPr>
-        <p:spPr>
-          <a:xfrm>
-            <a:off x="914400" y="1371600"/>
-            <a:ext cx="10360152" cy="365760"/>
-          </a:xfrm>
-          <a:prstGeom prst="rect">
-            <a:avLst/>
-          </a:prstGeom>
-          <a:noFill/>
-        </p:spPr>
-        <p:txBody>
-          <a:bodyPr wrap="square" lIns="0" rIns="0" tIns="0" bIns="0">
-            <a:spAutoFit/>
-          </a:bodyPr>
-          <a:lstStyle/>
-          <a:p>
-            <a:pPr>
-              <a:defRPr sz="1100" b="1">
-                <a:solidFill>
-                  <a:srgbClr val="0D9488"/>
-                </a:solidFill>
-                <a:latin typeface="Arial"/>
-              </a:defRPr>
-            </a:pPr>
-            <a:r>
-              <a:t>HACKHAZARDS '26 SUBMISSION  •  TEAM ARETE</a:t>
-            </a:r>
-          </a:p>
-        </p:txBody>
-      </p:sp>
-      <p:sp>
-        <p:nvSpPr>
-          <p:cNvPr id="4" name="TextBox 3"/>
-          <p:cNvSpPr txBox="1"/>
-          <p:nvPr/>
-        </p:nvSpPr>
-        <p:spPr>
-          <a:xfrm>
-            <a:off x="914400" y="1920240"/>
-            <a:ext cx="7772400" cy="2011680"/>
-          </a:xfrm>
-          <a:prstGeom prst="rect">
-            <a:avLst/>
-          </a:prstGeom>
-          <a:noFill/>
-        </p:spPr>
-        <p:txBody>
-          <a:bodyPr wrap="square" lIns="0" rIns="0" tIns="0" bIns="0">
-            <a:spAutoFit/>
-          </a:bodyPr>
-          <a:lstStyle/>
-          <a:p>
-            <a:pPr>
-              <a:lnSpc>
-                <a:spcPct val="95000"/>
-              </a:lnSpc>
-              <a:defRPr sz="6400" b="1">
-                <a:solidFill>
-                  <a:srgbClr val="0F172A"/>
-                </a:solidFill>
-                <a:latin typeface="Arial"/>
-              </a:defRPr>
-            </a:pPr>
-            <a:r>
-              <a:t>INTERNET</a:t>
-            </a:r>
-            <a:br/>
-            <a:r>
-              <a:t>BLACK BOX</a:t>
-            </a:r>
-          </a:p>
-        </p:txBody>
-      </p:sp>
-      <p:sp>
-        <p:nvSpPr>
-          <p:cNvPr id="5" name="Rectangle 4"/>
+          <p:cNvPr id="3" name="Rectangle 2"/>
           <p:cNvSpPr/>
           <p:nvPr/>
         </p:nvSpPr>
         <p:spPr>
           <a:xfrm>
-            <a:off x="914400" y="4114800"/>
-            <a:ext cx="4572000" cy="19050"/>
+            <a:off x="8549640" y="0"/>
+            <a:ext cx="36576" cy="6858000"/>
           </a:xfrm>
           <a:prstGeom prst="rect">
             <a:avLst/>
@@ -3270,14 +3189,14 @@
       </p:sp>
       <p:sp>
         <p:nvSpPr>
-          <p:cNvPr id="6" name="TextBox 5"/>
+          <p:cNvPr id="4" name="TextBox 3"/>
           <p:cNvSpPr txBox="1"/>
           <p:nvPr/>
         </p:nvSpPr>
         <p:spPr>
           <a:xfrm>
-            <a:off x="914400" y="4389120"/>
-            <a:ext cx="7315200" cy="731520"/>
+            <a:off x="914400" y="1097280"/>
+            <a:ext cx="10058400" cy="256032"/>
           </a:xfrm>
           <a:prstGeom prst="rect">
             <a:avLst/>
@@ -3291,48 +3210,29 @@
           <a:lstStyle/>
           <a:p>
             <a:pPr>
-              <a:defRPr sz="1800" b="1">
-                <a:solidFill>
-                  <a:srgbClr val="059669"/>
-                </a:solidFill>
-                <a:latin typeface="Arial"/>
-              </a:defRPr>
-            </a:pPr>
-            <a:r>
-              <a:t>Causal Incident Reconstruction — Hands-Free, Instant, and Autonomous.</a:t>
-            </a:r>
-          </a:p>
-          <a:p>
-            <a:pPr>
-              <a:lnSpc>
-                <a:spcPct val="130000"/>
-              </a:lnSpc>
-              <a:spcBef>
-                <a:spcPts val="800"/>
-              </a:spcBef>
-              <a:defRPr sz="1200">
-                <a:solidFill>
-                  <a:srgbClr val="475569"/>
-                </a:solidFill>
-                <a:latin typeface="Arial"/>
-              </a:defRPr>
-            </a:pPr>
-            <a:r>
-              <a:t>Passively mapping git merges, Slack triage discussions, and production alerts into an always-on causal event graph to trace outages to their root origins in seconds.</a:t>
-            </a:r>
-          </a:p>
-        </p:txBody>
-      </p:sp>
-      <p:sp>
-        <p:nvSpPr>
-          <p:cNvPr id="7" name="TextBox 6"/>
+              <a:defRPr sz="950" b="1">
+                <a:solidFill>
+                  <a:srgbClr val="0D9488"/>
+                </a:solidFill>
+                <a:latin typeface="Calibri"/>
+              </a:defRPr>
+            </a:pPr>
+            <a:r>
+              <a:t>HACKHAZARDS '26  ·  TEAM ARETE</a:t>
+            </a:r>
+          </a:p>
+        </p:txBody>
+      </p:sp>
+      <p:sp>
+        <p:nvSpPr>
+          <p:cNvPr id="5" name="TextBox 4"/>
           <p:cNvSpPr txBox="1"/>
           <p:nvPr/>
         </p:nvSpPr>
         <p:spPr>
           <a:xfrm>
-            <a:off x="914400" y="5760720"/>
-            <a:ext cx="10360152" cy="457200"/>
+            <a:off x="914400" y="1554480"/>
+            <a:ext cx="7315200" cy="2560320"/>
           </a:xfrm>
           <a:prstGeom prst="rect">
             <a:avLst/>
@@ -3346,15 +3246,336 @@
           <a:lstStyle/>
           <a:p>
             <a:pPr>
-              <a:defRPr sz="1000" b="1">
-                <a:solidFill>
-                  <a:srgbClr val="475569"/>
-                </a:solidFill>
-                <a:latin typeface="Arial"/>
-              </a:defRPr>
-            </a:pPr>
-            <a:r>
-              <a:t>TRACK SPONSORS:  Neo4j AuraDB  •  Render Workflows  •  Expo Mobile  •  Sarvam AI</a:t>
+              <a:lnSpc>
+                <a:spcPct val="90000"/>
+              </a:lnSpc>
+              <a:defRPr sz="7200" b="1">
+                <a:solidFill>
+                  <a:srgbClr val="0F172A"/>
+                </a:solidFill>
+                <a:latin typeface="Calibri"/>
+              </a:defRPr>
+            </a:pPr>
+            <a:r>
+              <a:t>Internet</a:t>
+            </a:r>
+          </a:p>
+          <a:p>
+            <a:pPr>
+              <a:lnSpc>
+                <a:spcPct val="90000"/>
+              </a:lnSpc>
+              <a:defRPr sz="7200" b="1">
+                <a:solidFill>
+                  <a:srgbClr val="059669"/>
+                </a:solidFill>
+                <a:latin typeface="Calibri"/>
+              </a:defRPr>
+            </a:pPr>
+            <a:r>
+              <a:t>Black Box</a:t>
+            </a:r>
+          </a:p>
+        </p:txBody>
+      </p:sp>
+      <p:sp>
+        <p:nvSpPr>
+          <p:cNvPr id="6" name="TextBox 5"/>
+          <p:cNvSpPr txBox="1"/>
+          <p:nvPr/>
+        </p:nvSpPr>
+        <p:spPr>
+          <a:xfrm>
+            <a:off x="914400" y="4206240"/>
+            <a:ext cx="7132320" cy="457200"/>
+          </a:xfrm>
+          <a:prstGeom prst="rect">
+            <a:avLst/>
+          </a:prstGeom>
+          <a:noFill/>
+        </p:spPr>
+        <p:txBody>
+          <a:bodyPr wrap="square" lIns="0" rIns="0" tIns="0" bIns="0">
+            <a:spAutoFit/>
+          </a:bodyPr>
+          <a:lstStyle/>
+          <a:p>
+            <a:pPr>
+              <a:defRPr sz="1600" b="0">
+                <a:solidFill>
+                  <a:srgbClr val="64748B"/>
+                </a:solidFill>
+                <a:latin typeface="Calibri"/>
+              </a:defRPr>
+            </a:pPr>
+            <a:r>
+              <a:t>Causal incident reconstruction — instant, hands-free, autonomous.</a:t>
+            </a:r>
+          </a:p>
+        </p:txBody>
+      </p:sp>
+      <p:sp>
+        <p:nvSpPr>
+          <p:cNvPr id="7" name="Rectangle 6"/>
+          <p:cNvSpPr/>
+          <p:nvPr/>
+        </p:nvSpPr>
+        <p:spPr>
+          <a:xfrm>
+            <a:off x="914400" y="4800600"/>
+            <a:ext cx="6400800" cy="15240"/>
+          </a:xfrm>
+          <a:prstGeom prst="rect">
+            <a:avLst/>
+          </a:prstGeom>
+          <a:solidFill>
+            <a:srgbClr val="059669"/>
+          </a:solidFill>
+          <a:ln>
+            <a:noFill/>
+          </a:ln>
+        </p:spPr>
+        <p:style>
+          <a:lnRef idx="1">
+            <a:schemeClr val="accent1"/>
+          </a:lnRef>
+          <a:fillRef idx="3">
+            <a:schemeClr val="accent1"/>
+          </a:fillRef>
+          <a:effectRef idx="2">
+            <a:schemeClr val="accent1"/>
+          </a:effectRef>
+          <a:fontRef idx="minor">
+            <a:schemeClr val="lt1"/>
+          </a:fontRef>
+        </p:style>
+        <p:txBody>
+          <a:bodyPr rtlCol="0" anchor="ctr"/>
+          <a:lstStyle/>
+          <a:p>
+            <a:pPr algn="ctr"/>
+          </a:p>
+        </p:txBody>
+      </p:sp>
+      <p:sp>
+        <p:nvSpPr>
+          <p:cNvPr id="8" name="TextBox 7"/>
+          <p:cNvSpPr txBox="1"/>
+          <p:nvPr/>
+        </p:nvSpPr>
+        <p:spPr>
+          <a:xfrm>
+            <a:off x="914400" y="4983480"/>
+            <a:ext cx="7132320" cy="1005840"/>
+          </a:xfrm>
+          <a:prstGeom prst="rect">
+            <a:avLst/>
+          </a:prstGeom>
+          <a:noFill/>
+        </p:spPr>
+        <p:txBody>
+          <a:bodyPr wrap="square" lIns="0" rIns="0" tIns="0" bIns="0">
+            <a:spAutoFit/>
+          </a:bodyPr>
+          <a:lstStyle/>
+          <a:p>
+            <a:pPr>
+              <a:lnSpc>
+                <a:spcPct val="140000"/>
+              </a:lnSpc>
+              <a:defRPr sz="1200">
+                <a:solidFill>
+                  <a:srgbClr val="64748B"/>
+                </a:solidFill>
+                <a:latin typeface="Calibri"/>
+              </a:defRPr>
+            </a:pPr>
+            <a:r>
+              <a:t>Passively ingesting Git merges, Slack triage threads, and production alerts into an always-on Neo4j causal event graph — tracing outages to their root origin in seconds, not days.</a:t>
+            </a:r>
+          </a:p>
+        </p:txBody>
+      </p:sp>
+      <p:sp>
+        <p:nvSpPr>
+          <p:cNvPr id="9" name="TextBox 8"/>
+          <p:cNvSpPr txBox="1"/>
+          <p:nvPr/>
+        </p:nvSpPr>
+        <p:spPr>
+          <a:xfrm>
+            <a:off x="8823960" y="1828800"/>
+            <a:ext cx="3017520" cy="3657600"/>
+          </a:xfrm>
+          <a:prstGeom prst="rect">
+            <a:avLst/>
+          </a:prstGeom>
+          <a:noFill/>
+        </p:spPr>
+        <p:txBody>
+          <a:bodyPr wrap="square" lIns="0" rIns="0" tIns="0" bIns="0">
+            <a:spAutoFit/>
+          </a:bodyPr>
+          <a:lstStyle/>
+          <a:p>
+            <a:pPr>
+              <a:spcBef>
+                <a:spcPts val="1400"/>
+              </a:spcBef>
+            </a:pPr>
+            <a:r>
+              <a:rPr sz="1000">
+                <a:solidFill>
+                  <a:srgbClr val="059669"/>
+                </a:solidFill>
+                <a:latin typeface="Calibri"/>
+              </a:rPr>
+              <a:t>◆  </a:t>
+            </a:r>
+            <a:r>
+              <a:rPr sz="1400" b="1">
+                <a:solidFill>
+                  <a:srgbClr val="0F172A"/>
+                </a:solidFill>
+                <a:latin typeface="Calibri"/>
+              </a:rPr>
+              <a:t>Neo4j AuraDB</a:t>
+            </a:r>
+          </a:p>
+          <a:p>
+            <a:pPr>
+              <a:spcBef>
+                <a:spcPts val="1400"/>
+              </a:spcBef>
+            </a:pPr>
+            <a:r>
+              <a:rPr sz="1000">
+                <a:solidFill>
+                  <a:srgbClr val="059669"/>
+                </a:solidFill>
+                <a:latin typeface="Calibri"/>
+              </a:rPr>
+              <a:t>◆  </a:t>
+            </a:r>
+            <a:r>
+              <a:rPr sz="1400" b="1">
+                <a:solidFill>
+                  <a:srgbClr val="0F172A"/>
+                </a:solidFill>
+                <a:latin typeface="Calibri"/>
+              </a:rPr>
+              <a:t>Render Workflows</a:t>
+            </a:r>
+          </a:p>
+          <a:p>
+            <a:pPr>
+              <a:spcBef>
+                <a:spcPts val="1400"/>
+              </a:spcBef>
+            </a:pPr>
+            <a:r>
+              <a:rPr sz="1000">
+                <a:solidFill>
+                  <a:srgbClr val="059669"/>
+                </a:solidFill>
+                <a:latin typeface="Calibri"/>
+              </a:rPr>
+              <a:t>◆  </a:t>
+            </a:r>
+            <a:r>
+              <a:rPr sz="1400" b="1">
+                <a:solidFill>
+                  <a:srgbClr val="0F172A"/>
+                </a:solidFill>
+                <a:latin typeface="Calibri"/>
+              </a:rPr>
+              <a:t>Expo Mobile</a:t>
+            </a:r>
+          </a:p>
+          <a:p>
+            <a:pPr>
+              <a:spcBef>
+                <a:spcPts val="1400"/>
+              </a:spcBef>
+            </a:pPr>
+            <a:r>
+              <a:rPr sz="1000">
+                <a:solidFill>
+                  <a:srgbClr val="059669"/>
+                </a:solidFill>
+                <a:latin typeface="Calibri"/>
+              </a:rPr>
+              <a:t>◆  </a:t>
+            </a:r>
+            <a:r>
+              <a:rPr sz="1400" b="1">
+                <a:solidFill>
+                  <a:srgbClr val="0F172A"/>
+                </a:solidFill>
+                <a:latin typeface="Calibri"/>
+              </a:rPr>
+              <a:t>Sarvam AI</a:t>
+            </a:r>
+          </a:p>
+          <a:p>
+            <a:pPr>
+              <a:spcBef>
+                <a:spcPts val="1400"/>
+              </a:spcBef>
+            </a:pPr>
+            <a:r>
+              <a:rPr sz="1000">
+                <a:solidFill>
+                  <a:srgbClr val="059669"/>
+                </a:solidFill>
+                <a:latin typeface="Calibri"/>
+              </a:rPr>
+              <a:t>◆  </a:t>
+            </a:r>
+            <a:r>
+              <a:rPr sz="1400" b="1">
+                <a:solidFill>
+                  <a:srgbClr val="0F172A"/>
+                </a:solidFill>
+                <a:latin typeface="Calibri"/>
+              </a:rPr>
+              <a:t>NVIDIA NIM</a:t>
+            </a:r>
+          </a:p>
+        </p:txBody>
+      </p:sp>
+      <p:sp>
+        <p:nvSpPr>
+          <p:cNvPr id="10" name="TextBox 9"/>
+          <p:cNvSpPr txBox="1"/>
+          <p:nvPr/>
+        </p:nvSpPr>
+        <p:spPr>
+          <a:xfrm>
+            <a:off x="8823960" y="1508760"/>
+            <a:ext cx="10058400" cy="256032"/>
+          </a:xfrm>
+          <a:prstGeom prst="rect">
+            <a:avLst/>
+          </a:prstGeom>
+          <a:noFill/>
+        </p:spPr>
+        <p:txBody>
+          <a:bodyPr wrap="square" lIns="0" rIns="0" tIns="0" bIns="0">
+            <a:spAutoFit/>
+          </a:bodyPr>
+          <a:lstStyle/>
+          <a:p>
+            <a:pPr>
+              <a:defRPr sz="950" b="1">
+                <a:solidFill>
+                  <a:srgbClr val="64748B"/>
+                </a:solidFill>
+                <a:latin typeface="Calibri"/>
+              </a:defRPr>
+            </a:pPr>
+            <a:r>
+              <a:t>TRACK SPONSORS</a:t>
             </a:r>
           </a:p>
         </p:txBody>
@@ -3373,7 +3594,7 @@
     <p:bg>
       <p:bgPr>
         <a:solidFill>
-          <a:srgbClr val="F8FAFC"/>
+          <a:srgbClr val="FAFBFC"/>
         </a:solidFill>
         <a:effectLst/>
       </p:bgPr>
@@ -3394,7 +3615,7 @@
         <p:spPr>
           <a:xfrm>
             <a:off x="914400" y="457200"/>
-            <a:ext cx="10360152" cy="274320"/>
+            <a:ext cx="10058400" cy="256032"/>
           </a:xfrm>
           <a:prstGeom prst="rect">
             <a:avLst/>
@@ -3408,15 +3629,15 @@
           <a:lstStyle/>
           <a:p>
             <a:pPr>
-              <a:defRPr sz="1000" b="1">
+              <a:defRPr sz="950" b="1">
                 <a:solidFill>
                   <a:srgbClr val="059669"/>
                 </a:solidFill>
-                <a:latin typeface="Arial"/>
-              </a:defRPr>
-            </a:pPr>
-            <a:r>
-              <a:t>01. PROBLEM LANDSCAPE</a:t>
+                <a:latin typeface="Calibri"/>
+              </a:defRPr>
+            </a:pPr>
+            <a:r>
+              <a:t>01  ·  PROBLEM LANDSCAPE</a:t>
             </a:r>
           </a:p>
         </p:txBody>
@@ -3429,8 +3650,8 @@
         </p:nvSpPr>
         <p:spPr>
           <a:xfrm>
-            <a:off x="914400" y="731520"/>
-            <a:ext cx="10360152" cy="640080"/>
+            <a:off x="914400" y="749808"/>
+            <a:ext cx="10058400" cy="822960"/>
           </a:xfrm>
           <a:prstGeom prst="rect">
             <a:avLst/>
@@ -3444,15 +3665,19 @@
           <a:lstStyle/>
           <a:p>
             <a:pPr>
-              <a:defRPr sz="3200" b="1">
+              <a:defRPr sz="3000" b="1">
                 <a:solidFill>
                   <a:srgbClr val="0F172A"/>
                 </a:solidFill>
-                <a:latin typeface="Arial"/>
-              </a:defRPr>
-            </a:pPr>
-            <a:r>
-              <a:t>Production Crashes. Diagnostics Stalls.</a:t>
+                <a:latin typeface="Calibri"/>
+              </a:defRPr>
+            </a:pPr>
+            <a:r>
+              <a:t>Outages strike at 3 AM.</a:t>
+            </a:r>
+            <a:br/>
+            <a:r>
+              <a:t>Forensics take 3 days.</a:t>
             </a:r>
           </a:p>
         </p:txBody>
@@ -3465,14 +3690,14 @@
         </p:nvSpPr>
         <p:spPr>
           <a:xfrm>
-            <a:off x="914400" y="1463040"/>
-            <a:ext cx="10362895" cy="19050"/>
+            <a:off x="914400" y="1627632"/>
+            <a:ext cx="10362895" cy="15240"/>
           </a:xfrm>
           <a:prstGeom prst="rect">
             <a:avLst/>
           </a:prstGeom>
           <a:solidFill>
-            <a:srgbClr val="E2E8F0"/>
+            <a:srgbClr val="CBD5E1"/>
           </a:solidFill>
           <a:ln>
             <a:noFill/>
@@ -3508,8 +3733,8 @@
         </p:nvSpPr>
         <p:spPr>
           <a:xfrm>
-            <a:off x="914400" y="2011680"/>
-            <a:ext cx="6217920" cy="4114800"/>
+            <a:off x="914400" y="1828800"/>
+            <a:ext cx="6400800" cy="548640"/>
           </a:xfrm>
           <a:prstGeom prst="rect">
             <a:avLst/>
@@ -3526,89 +3751,136 @@
               <a:lnSpc>
                 <a:spcPct val="140000"/>
               </a:lnSpc>
-              <a:spcAft>
-                <a:spcPts val="2000"/>
-              </a:spcAft>
-              <a:defRPr sz="1400">
-                <a:solidFill>
-                  <a:srgbClr val="475569"/>
-                </a:solidFill>
-                <a:latin typeface="Arial"/>
-              </a:defRPr>
-            </a:pPr>
-            <a:r>
-              <a:t>Software diagnostics resemble forensic archaeology. When systems fail, engineers must manually inspect fragmented, out-of-context telemetry logs, wasting hours cross-referencing timestamps.</a:t>
-            </a:r>
-          </a:p>
+              <a:defRPr sz="1350">
+                <a:solidFill>
+                  <a:srgbClr val="64748B"/>
+                </a:solidFill>
+                <a:latin typeface="Calibri"/>
+              </a:defRPr>
+            </a:pPr>
+            <a:r>
+              <a:t>When systems break, on-call engineers face an archaeology problem — evidence scattered across isolated, context-free silos.</a:t>
+            </a:r>
+          </a:p>
+        </p:txBody>
+      </p:sp>
+      <p:sp>
+        <p:nvSpPr>
+          <p:cNvPr id="6" name="TextBox 5"/>
+          <p:cNvSpPr txBox="1"/>
+          <p:nvPr/>
+        </p:nvSpPr>
+        <p:spPr>
+          <a:xfrm>
+            <a:off x="914400" y="2606040"/>
+            <a:ext cx="6309360" cy="3200400"/>
+          </a:xfrm>
+          <a:prstGeom prst="rect">
+            <a:avLst/>
+          </a:prstGeom>
+          <a:noFill/>
+        </p:spPr>
+        <p:txBody>
+          <a:bodyPr wrap="square" lIns="0" rIns="0" tIns="0" bIns="0">
+            <a:spAutoFit/>
+          </a:bodyPr>
+          <a:lstStyle/>
           <a:p>
             <a:pPr>
               <a:lnSpc>
-                <a:spcPct val="120000"/>
+                <a:spcPct val="125000"/>
               </a:lnSpc>
               <a:spcBef>
-                <a:spcPts val="1000"/>
+                <a:spcPts val="900"/>
               </a:spcBef>
-              <a:defRPr sz="1300">
-                <a:solidFill>
-                  <a:srgbClr val="0F172A"/>
-                </a:solidFill>
-                <a:latin typeface="Arial"/>
-              </a:defRPr>
-            </a:pPr>
-            <a:r>
-              <a:t>•  Flat Logs: Tell you what broke, but never who did it or why.</a:t>
+            </a:pPr>
+            <a:r>
+              <a:rPr sz="1300" b="1">
+                <a:solidFill>
+                  <a:srgbClr val="059669"/>
+                </a:solidFill>
+                <a:latin typeface="Calibri"/>
+              </a:rPr>
+              <a:t>▶  </a:t>
+            </a:r>
+            <a:r>
+              <a:rPr sz="1300">
+                <a:solidFill>
+                  <a:srgbClr val="334155"/>
+                </a:solidFill>
+                <a:latin typeface="Calibri"/>
+              </a:rPr>
+              <a:t>Git history records raw commits but strips away human decisions, Slack discussions, and deployment context.</a:t>
             </a:r>
           </a:p>
           <a:p>
             <a:pPr>
               <a:lnSpc>
-                <a:spcPct val="120000"/>
+                <a:spcPct val="125000"/>
               </a:lnSpc>
               <a:spcBef>
-                <a:spcPts val="1000"/>
+                <a:spcPts val="900"/>
               </a:spcBef>
-              <a:defRPr sz="1300">
-                <a:solidFill>
-                  <a:srgbClr val="0F172A"/>
-                </a:solidFill>
-                <a:latin typeface="Arial"/>
-              </a:defRPr>
-            </a:pPr>
-            <a:r>
-              <a:t>•  Developer Silos: Code edits in GitHub are disconnected from Slack War Rooms.</a:t>
+            </a:pPr>
+            <a:r>
+              <a:rPr sz="1300" b="1">
+                <a:solidFill>
+                  <a:srgbClr val="059669"/>
+                </a:solidFill>
+                <a:latin typeface="Calibri"/>
+              </a:rPr>
+              <a:t>▶  </a:t>
+            </a:r>
+            <a:r>
+              <a:rPr sz="1300">
+                <a:solidFill>
+                  <a:srgbClr val="334155"/>
+                </a:solidFill>
+                <a:latin typeface="Calibri"/>
+              </a:rPr>
+              <a:t>Slack war-room threads hold the 'why' but are disconnected from code changes or alert timelines.</a:t>
             </a:r>
           </a:p>
           <a:p>
             <a:pPr>
               <a:lnSpc>
-                <a:spcPct val="120000"/>
+                <a:spcPct val="125000"/>
               </a:lnSpc>
               <a:spcBef>
-                <a:spcPts val="1000"/>
+                <a:spcPts val="900"/>
               </a:spcBef>
-              <a:defRPr sz="1300">
-                <a:solidFill>
-                  <a:srgbClr val="0F172A"/>
-                </a:solidFill>
-                <a:latin typeface="Arial"/>
-              </a:defRPr>
-            </a:pPr>
-            <a:r>
-              <a:t>•  Alert Fatigue: Exception spikes occur without downstream causal paths.</a:t>
-            </a:r>
-          </a:p>
-        </p:txBody>
-      </p:sp>
-      <p:sp>
-        <p:nvSpPr>
-          <p:cNvPr id="6" name="Rectangle 5"/>
+            </a:pPr>
+            <a:r>
+              <a:rPr sz="1300" b="1">
+                <a:solidFill>
+                  <a:srgbClr val="059669"/>
+                </a:solidFill>
+                <a:latin typeface="Calibri"/>
+              </a:rPr>
+              <a:t>▶  </a:t>
+            </a:r>
+            <a:r>
+              <a:rPr sz="1300">
+                <a:solidFill>
+                  <a:srgbClr val="334155"/>
+                </a:solidFill>
+                <a:latin typeface="Calibri"/>
+              </a:rPr>
+              <a:t>Sentry / PagerDuty capture the crash — but can't link back to the breaking pull request or its author.</a:t>
+            </a:r>
+          </a:p>
+        </p:txBody>
+      </p:sp>
+      <p:sp>
+        <p:nvSpPr>
+          <p:cNvPr id="7" name="Rectangle 6"/>
           <p:cNvSpPr/>
           <p:nvPr/>
         </p:nvSpPr>
         <p:spPr>
           <a:xfrm>
-            <a:off x="7589520" y="2011680"/>
-            <a:ext cx="3657600" cy="3840480"/>
+            <a:off x="7589520" y="1828800"/>
+            <a:ext cx="3657600" cy="4114800"/>
           </a:xfrm>
           <a:prstGeom prst="rect">
             <a:avLst/>
@@ -3616,9 +3888,9 @@
           <a:solidFill>
             <a:srgbClr val="FFFFFF"/>
           </a:solidFill>
-          <a:ln w="19050">
+          <a:ln w="15240">
             <a:solidFill>
-              <a:srgbClr val="E2E8F0"/>
+              <a:srgbClr val="DCE3EB"/>
             </a:solidFill>
           </a:ln>
         </p:spPr>
@@ -3646,20 +3918,20 @@
       </p:sp>
       <p:sp>
         <p:nvSpPr>
-          <p:cNvPr id="7" name="Rectangle 6"/>
+          <p:cNvPr id="8" name="Rectangle 7"/>
           <p:cNvSpPr/>
           <p:nvPr/>
         </p:nvSpPr>
         <p:spPr>
           <a:xfrm>
-            <a:off x="7589520" y="2011680"/>
-            <a:ext cx="3657600" cy="73152"/>
+            <a:off x="7589520" y="1828800"/>
+            <a:ext cx="3657600" cy="64008"/>
           </a:xfrm>
           <a:prstGeom prst="rect">
             <a:avLst/>
           </a:prstGeom>
           <a:solidFill>
-            <a:srgbClr val="E11D48"/>
+            <a:srgbClr val="DC2626"/>
           </a:solidFill>
           <a:ln>
             <a:noFill/>
@@ -3689,14 +3961,14 @@
       </p:sp>
       <p:sp>
         <p:nvSpPr>
-          <p:cNvPr id="8" name="TextBox 7"/>
+          <p:cNvPr id="9" name="TextBox 8"/>
           <p:cNvSpPr txBox="1"/>
           <p:nvPr/>
         </p:nvSpPr>
         <p:spPr>
           <a:xfrm>
-            <a:off x="7955279" y="2286000"/>
-            <a:ext cx="2926080" cy="3291840"/>
+            <a:off x="7863840" y="2148840"/>
+            <a:ext cx="3200400" cy="3474720"/>
           </a:xfrm>
           <a:prstGeom prst="rect">
             <a:avLst/>
@@ -3710,73 +3982,101 @@
           <a:lstStyle/>
           <a:p>
             <a:pPr>
+              <a:spcBef>
+                <a:spcPts val="1600"/>
+              </a:spcBef>
               <a:spcAft>
-                <a:spcPts val="1500"/>
+                <a:spcPts val="1000"/>
               </a:spcAft>
-              <a:defRPr sz="1100" b="1">
-                <a:solidFill>
-                  <a:srgbClr val="E11D48"/>
-                </a:solidFill>
-                <a:latin typeface="Arial"/>
-              </a:defRPr>
-            </a:pPr>
-            <a:r>
-              <a:t>THE REACTION DELAY</a:t>
-            </a:r>
-          </a:p>
-          <a:p>
-            <a:pPr>
-              <a:defRPr sz="3600" b="1">
+              <a:defRPr sz="3000" b="1">
                 <a:solidFill>
                   <a:srgbClr val="0F172A"/>
                 </a:solidFill>
-                <a:latin typeface="Arial"/>
-              </a:defRPr>
-            </a:pPr>
-            <a:r>
-              <a:t>4.2 Hours</a:t>
+                <a:latin typeface="Calibri"/>
+              </a:defRPr>
+            </a:pPr>
+            <a:r>
+              <a:t>4.2 hrs</a:t>
             </a:r>
           </a:p>
           <a:p>
             <a:pPr>
               <a:spcAft>
-                <a:spcPts val="2000"/>
+                <a:spcPts val="400"/>
               </a:spcAft>
               <a:defRPr sz="1100">
                 <a:solidFill>
-                  <a:srgbClr val="475569"/>
-                </a:solidFill>
-                <a:latin typeface="Arial"/>
-              </a:defRPr>
-            </a:pPr>
-            <a:r>
-              <a:t>Average Mean Time to Resolution (MTTR) under standard debugging silos.</a:t>
-            </a:r>
-          </a:p>
-          <a:p>
-            <a:pPr>
-              <a:defRPr sz="3600" b="1">
+                  <a:srgbClr val="64748B"/>
+                </a:solidFill>
+                <a:latin typeface="Calibri"/>
+              </a:defRPr>
+            </a:pPr>
+            <a:r>
+              <a:t>Industry average MTTR (Mean Time to Resolve)</a:t>
+            </a:r>
+          </a:p>
+          <a:p>
+            <a:pPr>
+              <a:spcBef>
+                <a:spcPts val="1600"/>
+              </a:spcBef>
+              <a:defRPr sz="3000" b="1">
                 <a:solidFill>
                   <a:srgbClr val="0F172A"/>
                 </a:solidFill>
-                <a:latin typeface="Arial"/>
-              </a:defRPr>
-            </a:pPr>
-            <a:r>
-              <a:t>$300,000</a:t>
-            </a:r>
-          </a:p>
-          <a:p>
-            <a:pPr>
+                <a:latin typeface="Calibri"/>
+              </a:defRPr>
+            </a:pPr>
+            <a:r>
+              <a:t>$300K</a:t>
+            </a:r>
+          </a:p>
+          <a:p>
+            <a:pPr>
+              <a:spcAft>
+                <a:spcPts val="400"/>
+              </a:spcAft>
               <a:defRPr sz="1100">
                 <a:solidFill>
-                  <a:srgbClr val="475569"/>
-                </a:solidFill>
-                <a:latin typeface="Arial"/>
-              </a:defRPr>
-            </a:pPr>
-            <a:r>
-              <a:t>Average cost of hourly downtime for cloud software teams.</a:t>
+                  <a:srgbClr val="64748B"/>
+                </a:solidFill>
+                <a:latin typeface="Calibri"/>
+              </a:defRPr>
+            </a:pPr>
+            <a:r>
+              <a:t>Cost per hour of cloud production downtime</a:t>
+            </a:r>
+          </a:p>
+          <a:p>
+            <a:pPr>
+              <a:spcBef>
+                <a:spcPts val="1600"/>
+              </a:spcBef>
+              <a:defRPr sz="3000" b="1">
+                <a:solidFill>
+                  <a:srgbClr val="0F172A"/>
+                </a:solidFill>
+                <a:latin typeface="Calibri"/>
+              </a:defRPr>
+            </a:pPr>
+            <a:r>
+              <a:t>2–5 days</a:t>
+            </a:r>
+          </a:p>
+          <a:p>
+            <a:pPr>
+              <a:spcAft>
+                <a:spcPts val="400"/>
+              </a:spcAft>
+              <a:defRPr sz="1100">
+                <a:solidFill>
+                  <a:srgbClr val="64748B"/>
+                </a:solidFill>
+                <a:latin typeface="Calibri"/>
+              </a:defRPr>
+            </a:pPr>
+            <a:r>
+              <a:t>Typical post-mortem completion time</a:t>
             </a:r>
           </a:p>
         </p:txBody>
@@ -3795,7 +4095,7 @@
     <p:bg>
       <p:bgPr>
         <a:solidFill>
-          <a:srgbClr val="F8FAFC"/>
+          <a:srgbClr val="FAFBFC"/>
         </a:solidFill>
         <a:effectLst/>
       </p:bgPr>
@@ -3816,7 +4116,7 @@
         <p:spPr>
           <a:xfrm>
             <a:off x="914400" y="457200"/>
-            <a:ext cx="10360152" cy="274320"/>
+            <a:ext cx="10058400" cy="256032"/>
           </a:xfrm>
           <a:prstGeom prst="rect">
             <a:avLst/>
@@ -3830,15 +4130,15 @@
           <a:lstStyle/>
           <a:p>
             <a:pPr>
-              <a:defRPr sz="1000" b="1">
-                <a:solidFill>
-                  <a:srgbClr val="059669"/>
-                </a:solidFill>
-                <a:latin typeface="Arial"/>
-              </a:defRPr>
-            </a:pPr>
-            <a:r>
-              <a:t>02. THE GRAPH ENGINE</a:t>
+              <a:defRPr sz="950" b="1">
+                <a:solidFill>
+                  <a:srgbClr val="0D9488"/>
+                </a:solidFill>
+                <a:latin typeface="Calibri"/>
+              </a:defRPr>
+            </a:pPr>
+            <a:r>
+              <a:t>02  ·  THE GRAPH ENGINE</a:t>
             </a:r>
           </a:p>
         </p:txBody>
@@ -3851,8 +4151,8 @@
         </p:nvSpPr>
         <p:spPr>
           <a:xfrm>
-            <a:off x="914400" y="731520"/>
-            <a:ext cx="10360152" cy="640080"/>
+            <a:off x="914400" y="749808"/>
+            <a:ext cx="10058400" cy="822960"/>
           </a:xfrm>
           <a:prstGeom prst="rect">
             <a:avLst/>
@@ -3866,15 +4166,15 @@
           <a:lstStyle/>
           <a:p>
             <a:pPr>
-              <a:defRPr sz="3200" b="1">
+              <a:defRPr sz="3000" b="1">
                 <a:solidFill>
                   <a:srgbClr val="0F172A"/>
                 </a:solidFill>
-                <a:latin typeface="Arial"/>
-              </a:defRPr>
-            </a:pPr>
-            <a:r>
-              <a:t>Neo4j AuraDB Causal Event Topology</a:t>
+                <a:latin typeface="Calibri"/>
+              </a:defRPr>
+            </a:pPr>
+            <a:r>
+              <a:t>Neo4j AuraDB — Causality over columns.</a:t>
             </a:r>
           </a:p>
         </p:txBody>
@@ -3887,14 +4187,14 @@
         </p:nvSpPr>
         <p:spPr>
           <a:xfrm>
-            <a:off x="914400" y="1463040"/>
-            <a:ext cx="10362895" cy="19050"/>
+            <a:off x="914400" y="1627632"/>
+            <a:ext cx="10362895" cy="15240"/>
           </a:xfrm>
           <a:prstGeom prst="rect">
             <a:avLst/>
           </a:prstGeom>
           <a:solidFill>
-            <a:srgbClr val="E2E8F0"/>
+            <a:srgbClr val="CBD5E1"/>
           </a:solidFill>
           <a:ln>
             <a:noFill/>
@@ -3930,8 +4230,8 @@
         </p:nvSpPr>
         <p:spPr>
           <a:xfrm>
-            <a:off x="914400" y="2011680"/>
-            <a:ext cx="6217920" cy="4114800"/>
+            <a:off x="914400" y="1828800"/>
+            <a:ext cx="6400800" cy="502920"/>
           </a:xfrm>
           <a:prstGeom prst="rect">
             <a:avLst/>
@@ -3948,99 +4248,146 @@
               <a:lnSpc>
                 <a:spcPct val="140000"/>
               </a:lnSpc>
-              <a:spcAft>
-                <a:spcPts val="2000"/>
-              </a:spcAft>
-              <a:defRPr sz="1400">
-                <a:solidFill>
-                  <a:srgbClr val="475569"/>
-                </a:solidFill>
-                <a:latin typeface="Arial"/>
-              </a:defRPr>
-            </a:pPr>
-            <a:r>
-              <a:t>Rather than matching logs via expensive SQL join queries, Internet Black Box maps telemetry as nodes and relations, executing index-free adjacency traversals.</a:t>
-            </a:r>
-          </a:p>
+              <a:defRPr sz="1350">
+                <a:solidFill>
+                  <a:srgbClr val="64748B"/>
+                </a:solidFill>
+                <a:latin typeface="Calibri"/>
+              </a:defRPr>
+            </a:pPr>
+            <a:r>
+              <a:t>Native graph gives us index-free adjacency: constant-time causal traversal — no joins, no scans.</a:t>
+            </a:r>
+          </a:p>
+        </p:txBody>
+      </p:sp>
+      <p:sp>
+        <p:nvSpPr>
+          <p:cNvPr id="6" name="TextBox 5"/>
+          <p:cNvSpPr txBox="1"/>
+          <p:nvPr/>
+        </p:nvSpPr>
+        <p:spPr>
+          <a:xfrm>
+            <a:off x="914400" y="2514600"/>
+            <a:ext cx="6309360" cy="3383280"/>
+          </a:xfrm>
+          <a:prstGeom prst="rect">
+            <a:avLst/>
+          </a:prstGeom>
+          <a:noFill/>
+        </p:spPr>
+        <p:txBody>
+          <a:bodyPr wrap="square" lIns="0" rIns="0" tIns="0" bIns="0">
+            <a:spAutoFit/>
+          </a:bodyPr>
+          <a:lstStyle/>
           <a:p>
             <a:pPr>
               <a:lnSpc>
-                <a:spcPct val="120000"/>
+                <a:spcPct val="125000"/>
               </a:lnSpc>
               <a:spcBef>
-                <a:spcPts val="1000"/>
+                <a:spcPts val="900"/>
               </a:spcBef>
-              <a:defRPr sz="1300">
-                <a:solidFill>
-                  <a:srgbClr val="0F172A"/>
-                </a:solidFill>
-                <a:latin typeface="Arial"/>
-              </a:defRPr>
-            </a:pPr>
-            <a:r>
-              <a:t>✔  Semantic Node Entities: System, File, Person, Event, Incident.</a:t>
+            </a:pPr>
+            <a:r>
+              <a:rPr sz="1300" b="1">
+                <a:solidFill>
+                  <a:srgbClr val="0D9488"/>
+                </a:solidFill>
+                <a:latin typeface="Calibri"/>
+              </a:rPr>
+              <a:t>◉  </a:t>
+            </a:r>
+            <a:r>
+              <a:rPr sz="1300">
+                <a:solidFill>
+                  <a:srgbClr val="334155"/>
+                </a:solidFill>
+                <a:latin typeface="Calibri"/>
+              </a:rPr>
+              <a:t>Node types: Person · Commit · PullRequest · Deployment · Alert · Incident · System</a:t>
             </a:r>
           </a:p>
           <a:p>
             <a:pPr>
               <a:lnSpc>
-                <a:spcPct val="120000"/>
+                <a:spcPct val="125000"/>
               </a:lnSpc>
               <a:spcBef>
-                <a:spcPts val="1000"/>
+                <a:spcPts val="900"/>
               </a:spcBef>
-              <a:defRPr sz="1300">
-                <a:solidFill>
-                  <a:srgbClr val="0F172A"/>
-                </a:solidFill>
-                <a:latin typeface="Arial"/>
-              </a:defRPr>
-            </a:pPr>
-            <a:r>
-              <a:t>✔  Causal Edge Paths: Nodes are contextually wired with :AUTHORED, :DEPLOYED_TO, :TRIGGERED, and :CAUSED_BY relationships.</a:t>
+            </a:pPr>
+            <a:r>
+              <a:rPr sz="1300" b="1">
+                <a:solidFill>
+                  <a:srgbClr val="0D9488"/>
+                </a:solidFill>
+                <a:latin typeface="Calibri"/>
+              </a:rPr>
+              <a:t>◉  </a:t>
+            </a:r>
+            <a:r>
+              <a:rPr sz="1300">
+                <a:solidFill>
+                  <a:srgbClr val="334155"/>
+                </a:solidFill>
+                <a:latin typeface="Calibri"/>
+              </a:rPr>
+              <a:t>Edge semantics: :AUTHORED  :TRIGGERED  :DEPLOYED_TO  :AFFECTED  :CAUSED_BY</a:t>
             </a:r>
           </a:p>
           <a:p>
             <a:pPr>
               <a:lnSpc>
-                <a:spcPct val="120000"/>
+                <a:spcPct val="125000"/>
               </a:lnSpc>
               <a:spcBef>
-                <a:spcPts val="1000"/>
+                <a:spcPts val="900"/>
               </a:spcBef>
-              <a:defRPr sz="1300">
-                <a:solidFill>
-                  <a:srgbClr val="0F172A"/>
-                </a:solidFill>
-                <a:latin typeface="Arial"/>
-              </a:defRPr>
-            </a:pPr>
-            <a:r>
-              <a:t>✔  Immediate Identification: Trace back from a Sentry exception directly to the breaking commit SHA in under 50ms.</a:t>
-            </a:r>
-          </a:p>
-        </p:txBody>
-      </p:sp>
-      <p:sp>
-        <p:nvSpPr>
-          <p:cNvPr id="6" name="Rectangle 5"/>
+            </a:pPr>
+            <a:r>
+              <a:rPr sz="1300" b="1">
+                <a:solidFill>
+                  <a:srgbClr val="0D9488"/>
+                </a:solidFill>
+                <a:latin typeface="Calibri"/>
+              </a:rPr>
+              <a:t>◉  </a:t>
+            </a:r>
+            <a:r>
+              <a:rPr sz="1300">
+                <a:solidFill>
+                  <a:srgbClr val="334155"/>
+                </a:solidFill>
+                <a:latin typeface="Calibri"/>
+              </a:rPr>
+              <a:t>Shortest-path Cypher traces from production alert → breaking commit → author in &lt;50 ms.</a:t>
+            </a:r>
+          </a:p>
+        </p:txBody>
+      </p:sp>
+      <p:sp>
+        <p:nvSpPr>
+          <p:cNvPr id="7" name="Rectangle 6"/>
           <p:cNvSpPr/>
           <p:nvPr/>
         </p:nvSpPr>
         <p:spPr>
           <a:xfrm>
-            <a:off x="7589520" y="2011680"/>
-            <a:ext cx="3657600" cy="3840480"/>
+            <a:off x="7589520" y="1828800"/>
+            <a:ext cx="3657600" cy="4114800"/>
           </a:xfrm>
           <a:prstGeom prst="rect">
             <a:avLst/>
           </a:prstGeom>
           <a:solidFill>
-            <a:srgbClr val="F1F5F9"/>
+            <a:srgbClr val="FFFFFF"/>
           </a:solidFill>
-          <a:ln w="19050">
+          <a:ln w="15240">
             <a:solidFill>
-              <a:srgbClr val="E2E8F0"/>
+              <a:srgbClr val="DCE3EB"/>
             </a:solidFill>
           </a:ln>
         </p:spPr>
@@ -4068,14 +4415,14 @@
       </p:sp>
       <p:sp>
         <p:nvSpPr>
-          <p:cNvPr id="7" name="Rectangle 6"/>
+          <p:cNvPr id="8" name="Rectangle 7"/>
           <p:cNvSpPr/>
           <p:nvPr/>
         </p:nvSpPr>
         <p:spPr>
           <a:xfrm>
-            <a:off x="7589520" y="2011680"/>
-            <a:ext cx="3657600" cy="73152"/>
+            <a:off x="7589520" y="1828800"/>
+            <a:ext cx="3657600" cy="64008"/>
           </a:xfrm>
           <a:prstGeom prst="rect">
             <a:avLst/>
@@ -4111,14 +4458,57 @@
       </p:sp>
       <p:sp>
         <p:nvSpPr>
-          <p:cNvPr id="8" name="TextBox 7"/>
+          <p:cNvPr id="9" name="Rectangle 8"/>
+          <p:cNvSpPr/>
+          <p:nvPr/>
+        </p:nvSpPr>
+        <p:spPr>
+          <a:xfrm>
+            <a:off x="7589520" y="1892807"/>
+            <a:ext cx="3657600" cy="4050791"/>
+          </a:xfrm>
+          <a:prstGeom prst="rect">
+            <a:avLst/>
+          </a:prstGeom>
+          <a:solidFill>
+            <a:srgbClr val="F1F5F9"/>
+          </a:solidFill>
+          <a:ln>
+            <a:noFill/>
+          </a:ln>
+        </p:spPr>
+        <p:style>
+          <a:lnRef idx="1">
+            <a:schemeClr val="accent1"/>
+          </a:lnRef>
+          <a:fillRef idx="3">
+            <a:schemeClr val="accent1"/>
+          </a:fillRef>
+          <a:effectRef idx="2">
+            <a:schemeClr val="accent1"/>
+          </a:effectRef>
+          <a:fontRef idx="minor">
+            <a:schemeClr val="lt1"/>
+          </a:fontRef>
+        </p:style>
+        <p:txBody>
+          <a:bodyPr rtlCol="0" anchor="ctr"/>
+          <a:lstStyle/>
+          <a:p>
+            <a:pPr algn="ctr"/>
+          </a:p>
+        </p:txBody>
+      </p:sp>
+      <p:sp>
+        <p:nvSpPr>
+          <p:cNvPr id="10" name="TextBox 9"/>
           <p:cNvSpPr txBox="1"/>
           <p:nvPr/>
         </p:nvSpPr>
         <p:spPr>
           <a:xfrm>
-            <a:off x="7955279" y="2286000"/>
-            <a:ext cx="2926080" cy="3291840"/>
+            <a:off x="7818120" y="2057400"/>
+            <a:ext cx="3246120" cy="3657600"/>
           </a:xfrm>
           <a:prstGeom prst="rect">
             <a:avLst/>
@@ -4133,17 +4523,17 @@
           <a:p>
             <a:pPr>
               <a:spcAft>
-                <a:spcPts val="1500"/>
+                <a:spcPts val="600"/>
               </a:spcAft>
-              <a:defRPr sz="1100" b="1">
-                <a:solidFill>
-                  <a:srgbClr val="0D9488"/>
-                </a:solidFill>
-                <a:latin typeface="Arial"/>
-              </a:defRPr>
-            </a:pPr>
-            <a:r>
-              <a:t>NEO4J ROOT-CAUSE CYPHER</a:t>
+              <a:defRPr sz="950">
+                <a:solidFill>
+                  <a:srgbClr val="64748B"/>
+                </a:solidFill>
+                <a:latin typeface="Lucida Console"/>
+              </a:defRPr>
+            </a:pPr>
+            <a:r>
+              <a:t>// Root-cause Cypher query</a:t>
             </a:r>
           </a:p>
           <a:p>
@@ -4151,15 +4541,24 @@
               <a:spcBef>
                 <a:spcPts val="200"/>
               </a:spcBef>
-              <a:defRPr sz="1200" b="1">
+            </a:pPr>
+            <a:r>
+              <a:rPr sz="1100" b="1">
+                <a:solidFill>
+                  <a:srgbClr val="0D9488"/>
+                </a:solidFill>
+                <a:latin typeface="Lucida Console"/>
+              </a:rPr>
+              <a:t>MATCH</a:t>
+            </a:r>
+            <a:r>
+              <a:rPr sz="1100">
                 <a:solidFill>
                   <a:srgbClr val="0F172A"/>
                 </a:solidFill>
-                <a:latin typeface="Courier New"/>
-              </a:defRPr>
-            </a:pPr>
-            <a:r>
-              <a:t>MATCH (i:Incident {id: $id})</a:t>
+                <a:latin typeface="Lucida Console"/>
+              </a:rPr>
+              <a:t> (i:Incident {id: $incidentId})</a:t>
             </a:r>
           </a:p>
           <a:p>
@@ -4167,15 +4566,24 @@
               <a:spcBef>
                 <a:spcPts val="200"/>
               </a:spcBef>
-              <a:defRPr sz="1200" b="1">
+            </a:pPr>
+            <a:r>
+              <a:rPr sz="1100" b="1">
+                <a:solidFill>
+                  <a:srgbClr val="0D9488"/>
+                </a:solidFill>
+                <a:latin typeface="Lucida Console"/>
+              </a:rPr>
+              <a:t>MATCH</a:t>
+            </a:r>
+            <a:r>
+              <a:rPr sz="1100">
                 <a:solidFill>
                   <a:srgbClr val="0F172A"/>
                 </a:solidFill>
-                <a:latin typeface="Courier New"/>
-              </a:defRPr>
-            </a:pPr>
-            <a:r>
-              <a:t>MATCH path = shortestPath(</a:t>
+                <a:latin typeface="Lucida Console"/>
+              </a:rPr>
+              <a:t> path = shortestPath(</a:t>
             </a:r>
           </a:p>
           <a:p>
@@ -4183,15 +4591,24 @@
               <a:spcBef>
                 <a:spcPts val="200"/>
               </a:spcBef>
-              <a:defRPr sz="1200" b="1">
+            </a:pPr>
+            <a:r>
+              <a:rPr sz="1100" b="1">
+                <a:solidFill>
+                  <a:srgbClr val="0D9488"/>
+                </a:solidFill>
+                <a:latin typeface="Lucida Console"/>
+              </a:rPr>
+              <a:t>  </a:t>
+            </a:r>
+            <a:r>
+              <a:rPr sz="1100">
                 <a:solidFill>
                   <a:srgbClr val="0F172A"/>
                 </a:solidFill>
-                <a:latin typeface="Courier New"/>
-              </a:defRPr>
-            </a:pPr>
-            <a:r>
-              <a:t>  (c:Event {type: 'COMMIT'})</a:t>
+                <a:latin typeface="Lucida Console"/>
+              </a:rPr>
+              <a:t>(c:Event {type: 'COMMIT'})</a:t>
             </a:r>
           </a:p>
           <a:p>
@@ -4199,15 +4616,24 @@
               <a:spcBef>
                 <a:spcPts val="200"/>
               </a:spcBef>
-              <a:defRPr sz="1200" b="1">
+            </a:pPr>
+            <a:r>
+              <a:rPr sz="1100" b="1">
+                <a:solidFill>
+                  <a:srgbClr val="0D9488"/>
+                </a:solidFill>
+                <a:latin typeface="Lucida Console"/>
+              </a:rPr>
+              <a:t>  </a:t>
+            </a:r>
+            <a:r>
+              <a:rPr sz="1100">
                 <a:solidFill>
                   <a:srgbClr val="0F172A"/>
                 </a:solidFill>
-                <a:latin typeface="Courier New"/>
-              </a:defRPr>
-            </a:pPr>
-            <a:r>
-              <a:t>  -[:TRIGGERED|PRECEDED*1..5]-&gt;</a:t>
+                <a:latin typeface="Lucida Console"/>
+              </a:rPr>
+              <a:t>-[:TRIGGERED|PRECEDED*1..6]-&gt;</a:t>
             </a:r>
           </a:p>
           <a:p>
@@ -4215,15 +4641,24 @@
               <a:spcBef>
                 <a:spcPts val="200"/>
               </a:spcBef>
-              <a:defRPr sz="1200" b="1">
+            </a:pPr>
+            <a:r>
+              <a:rPr sz="1100" b="1">
+                <a:solidFill>
+                  <a:srgbClr val="0D9488"/>
+                </a:solidFill>
+                <a:latin typeface="Lucida Console"/>
+              </a:rPr>
+              <a:t>  </a:t>
+            </a:r>
+            <a:r>
+              <a:rPr sz="1100">
                 <a:solidFill>
                   <a:srgbClr val="0F172A"/>
                 </a:solidFill>
-                <a:latin typeface="Courier New"/>
-              </a:defRPr>
-            </a:pPr>
-            <a:r>
-              <a:t>  (i)</a:t>
+                <a:latin typeface="Lucida Console"/>
+              </a:rPr>
+              <a:t>(i)</a:t>
             </a:r>
           </a:p>
           <a:p>
@@ -4231,15 +4666,24 @@
               <a:spcBef>
                 <a:spcPts val="200"/>
               </a:spcBef>
-              <a:defRPr sz="1200" b="1">
+            </a:pPr>
+            <a:r>
+              <a:rPr sz="1100" b="1">
+                <a:solidFill>
+                  <a:srgbClr val="0D9488"/>
+                </a:solidFill>
+                <a:latin typeface="Lucida Console"/>
+              </a:rPr>
+              <a:t>)</a:t>
+            </a:r>
+            <a:r>
+              <a:rPr sz="1100">
                 <a:solidFill>
                   <a:srgbClr val="0F172A"/>
                 </a:solidFill>
-                <a:latin typeface="Courier New"/>
-              </a:defRPr>
-            </a:pPr>
-            <a:r>
-              <a:t>)</a:t>
+                <a:latin typeface="Lucida Console"/>
+              </a:rPr>
+              <a:t/>
             </a:r>
           </a:p>
           <a:p>
@@ -4247,31 +4691,40 @@
               <a:spcBef>
                 <a:spcPts val="200"/>
               </a:spcBef>
-              <a:defRPr sz="1200" b="1">
+            </a:pPr>
+            <a:r>
+              <a:rPr sz="1100" b="1">
+                <a:solidFill>
+                  <a:srgbClr val="0D9488"/>
+                </a:solidFill>
+                <a:latin typeface="Lucida Console"/>
+              </a:rPr>
+              <a:t>RETURN</a:t>
+            </a:r>
+            <a:r>
+              <a:rPr sz="1100">
                 <a:solidFill>
                   <a:srgbClr val="0F172A"/>
                 </a:solidFill>
-                <a:latin typeface="Courier New"/>
-              </a:defRPr>
-            </a:pPr>
-            <a:r>
-              <a:t>RETURN path</a:t>
+                <a:latin typeface="Lucida Console"/>
+              </a:rPr>
+              <a:t> nodes(path), relationships(path)</a:t>
             </a:r>
           </a:p>
           <a:p>
             <a:pPr>
               <a:spcBef>
-                <a:spcPts val="1500"/>
+                <a:spcPts val="1400"/>
               </a:spcBef>
-              <a:defRPr sz="1000">
-                <a:solidFill>
-                  <a:srgbClr val="475569"/>
-                </a:solidFill>
-                <a:latin typeface="Arial"/>
-              </a:defRPr>
-            </a:pPr>
-            <a:r>
-              <a:t>⚡ Traverses the causality pipeline from crash to git merge in constant time.</a:t>
+              <a:defRPr sz="1000" b="1">
+                <a:solidFill>
+                  <a:srgbClr val="059669"/>
+                </a:solidFill>
+                <a:latin typeface="Calibri"/>
+              </a:defRPr>
+            </a:pPr>
+            <a:r>
+              <a:t>⚡ Returns full causal path in &lt;50 ms</a:t>
             </a:r>
           </a:p>
         </p:txBody>
@@ -4290,7 +4743,7 @@
     <p:bg>
       <p:bgPr>
         <a:solidFill>
-          <a:srgbClr val="F8FAFC"/>
+          <a:srgbClr val="FAFBFC"/>
         </a:solidFill>
         <a:effectLst/>
       </p:bgPr>
@@ -4311,7 +4764,7 @@
         <p:spPr>
           <a:xfrm>
             <a:off x="914400" y="457200"/>
-            <a:ext cx="10360152" cy="274320"/>
+            <a:ext cx="10058400" cy="256032"/>
           </a:xfrm>
           <a:prstGeom prst="rect">
             <a:avLst/>
@@ -4325,15 +4778,15 @@
           <a:lstStyle/>
           <a:p>
             <a:pPr>
-              <a:defRPr sz="1000" b="1">
+              <a:defRPr sz="950" b="1">
                 <a:solidFill>
                   <a:srgbClr val="059669"/>
                 </a:solidFill>
-                <a:latin typeface="Arial"/>
-              </a:defRPr>
-            </a:pPr>
-            <a:r>
-              <a:t>03. INGESTION PIPELINES</a:t>
+                <a:latin typeface="Calibri"/>
+              </a:defRPr>
+            </a:pPr>
+            <a:r>
+              <a:t>03  ·  INGESTION ARCHITECTURE</a:t>
             </a:r>
           </a:p>
         </p:txBody>
@@ -4346,8 +4799,8 @@
         </p:nvSpPr>
         <p:spPr>
           <a:xfrm>
-            <a:off x="914400" y="731520"/>
-            <a:ext cx="10360152" cy="640080"/>
+            <a:off x="914400" y="749808"/>
+            <a:ext cx="10058400" cy="822960"/>
           </a:xfrm>
           <a:prstGeom prst="rect">
             <a:avLst/>
@@ -4361,15 +4814,15 @@
           <a:lstStyle/>
           <a:p>
             <a:pPr>
-              <a:defRPr sz="3200" b="1">
+              <a:defRPr sz="3000" b="1">
                 <a:solidFill>
                   <a:srgbClr val="0F172A"/>
                 </a:solidFill>
-                <a:latin typeface="Arial"/>
-              </a:defRPr>
-            </a:pPr>
-            <a:r>
-              <a:t>Render Background Ingestion Architecture</a:t>
+                <a:latin typeface="Calibri"/>
+              </a:defRPr>
+            </a:pPr>
+            <a:r>
+              <a:t>Render Workflows — multi-stage passive capture.</a:t>
             </a:r>
           </a:p>
         </p:txBody>
@@ -4382,14 +4835,14 @@
         </p:nvSpPr>
         <p:spPr>
           <a:xfrm>
-            <a:off x="914400" y="1463040"/>
-            <a:ext cx="10362895" cy="19050"/>
+            <a:off x="914400" y="1627632"/>
+            <a:ext cx="10362895" cy="15240"/>
           </a:xfrm>
           <a:prstGeom prst="rect">
             <a:avLst/>
           </a:prstGeom>
           <a:solidFill>
-            <a:srgbClr val="E2E8F0"/>
+            <a:srgbClr val="CBD5E1"/>
           </a:solidFill>
           <a:ln>
             <a:noFill/>
@@ -4425,8 +4878,8 @@
         </p:nvSpPr>
         <p:spPr>
           <a:xfrm>
-            <a:off x="914400" y="2011680"/>
-            <a:ext cx="3200400" cy="3931920"/>
+            <a:off x="914400" y="1828800"/>
+            <a:ext cx="3200400" cy="4023360"/>
           </a:xfrm>
           <a:prstGeom prst="rect">
             <a:avLst/>
@@ -4434,9 +4887,9 @@
           <a:solidFill>
             <a:srgbClr val="FFFFFF"/>
           </a:solidFill>
-          <a:ln w="19050">
+          <a:ln w="15240">
             <a:solidFill>
-              <a:srgbClr val="E2E8F0"/>
+              <a:srgbClr val="DCE3EB"/>
             </a:solidFill>
           </a:ln>
         </p:spPr>
@@ -4470,8 +4923,8 @@
         </p:nvSpPr>
         <p:spPr>
           <a:xfrm>
-            <a:off x="914400" y="2011680"/>
-            <a:ext cx="3200400" cy="73152"/>
+            <a:off x="914400" y="1828800"/>
+            <a:ext cx="3200400" cy="64008"/>
           </a:xfrm>
           <a:prstGeom prst="rect">
             <a:avLst/>
@@ -4513,8 +4966,8 @@
         </p:nvSpPr>
         <p:spPr>
           <a:xfrm>
-            <a:off x="1143000" y="2331720"/>
-            <a:ext cx="2743200" cy="3291840"/>
+            <a:off x="1170432" y="2084832"/>
+            <a:ext cx="2688336" cy="3566160"/>
           </a:xfrm>
           <a:prstGeom prst="rect">
             <a:avLst/>
@@ -4529,17 +4982,37 @@
           <a:p>
             <a:pPr>
               <a:spcAft>
-                <a:spcPts val="1000"/>
+                <a:spcPts val="800"/>
               </a:spcAft>
-              <a:defRPr sz="1000" b="1">
+              <a:defRPr sz="900" b="1">
                 <a:solidFill>
                   <a:srgbClr val="059669"/>
                 </a:solidFill>
-                <a:latin typeface="Arial"/>
-              </a:defRPr>
-            </a:pPr>
-            <a:r>
-              <a:t>01  •  `ingest-github`</a:t>
+                <a:latin typeface="Calibri"/>
+              </a:defRPr>
+            </a:pPr>
+            <a:r>
+              <a:t>01  ·  INGEST-GITHUB</a:t>
+            </a:r>
+          </a:p>
+          <a:p>
+            <a:pPr>
+              <a:spcAft>
+                <a:spcPts val="1200"/>
+              </a:spcAft>
+              <a:defRPr sz="1700" b="1">
+                <a:solidFill>
+                  <a:srgbClr val="0F172A"/>
+                </a:solidFill>
+                <a:latin typeface="Calibri"/>
+              </a:defRPr>
+            </a:pPr>
+            <a:r>
+              <a:t>Cron Sync</a:t>
+            </a:r>
+            <a:br/>
+            <a:r>
+              <a:t>Job</a:t>
             </a:r>
           </a:p>
           <a:p>
@@ -4547,31 +5020,31 @@
               <a:spcAft>
                 <a:spcPts val="1000"/>
               </a:spcAft>
-              <a:defRPr sz="1800" b="1">
-                <a:solidFill>
-                  <a:srgbClr val="0F172A"/>
-                </a:solidFill>
-                <a:latin typeface="Arial"/>
-              </a:defRPr>
-            </a:pPr>
-            <a:r>
-              <a:t>Cron Job Ingest</a:t>
+              <a:defRPr sz="700">
+                <a:solidFill>
+                  <a:srgbClr val="DCE3EB"/>
+                </a:solidFill>
+                <a:latin typeface="Calibri"/>
+              </a:defRPr>
+            </a:pPr>
+            <a:r>
+              <a:t>────────────────────────────────</a:t>
             </a:r>
           </a:p>
           <a:p>
             <a:pPr>
               <a:lnSpc>
-                <a:spcPct val="130000"/>
+                <a:spcPct val="135000"/>
               </a:lnSpc>
               <a:defRPr sz="1200">
                 <a:solidFill>
-                  <a:srgbClr val="475569"/>
-                </a:solidFill>
-                <a:latin typeface="Arial"/>
-              </a:defRPr>
-            </a:pPr>
-            <a:r>
-              <a:t>Runs on a recurring 5-minute interval. Queries GitHub repositories for commits, pull request lifecycle stages, file modifications, and deployment states, generating semantic node mappings.</a:t>
+                  <a:srgbClr val="64748B"/>
+                </a:solidFill>
+                <a:latin typeface="Calibri"/>
+              </a:defRPr>
+            </a:pPr>
+            <a:r>
+              <a:t>Runs every 5 minutes via Render cron. Queries GitHub for commits, PR lifecycle events, file diffs, and deployment states. Writes semantic node-edge pairs to Neo4j.</a:t>
             </a:r>
           </a:p>
         </p:txBody>
@@ -4584,8 +5057,8 @@
         </p:nvSpPr>
         <p:spPr>
           <a:xfrm>
-            <a:off x="4480560" y="2011680"/>
-            <a:ext cx="3200400" cy="3931920"/>
+            <a:off x="4495190" y="1828800"/>
+            <a:ext cx="3200400" cy="4023360"/>
           </a:xfrm>
           <a:prstGeom prst="rect">
             <a:avLst/>
@@ -4593,9 +5066,9 @@
           <a:solidFill>
             <a:srgbClr val="FFFFFF"/>
           </a:solidFill>
-          <a:ln w="19050">
+          <a:ln w="15240">
             <a:solidFill>
-              <a:srgbClr val="E2E8F0"/>
+              <a:srgbClr val="DCE3EB"/>
             </a:solidFill>
           </a:ln>
         </p:spPr>
@@ -4629,8 +5102,8 @@
         </p:nvSpPr>
         <p:spPr>
           <a:xfrm>
-            <a:off x="4480560" y="2011680"/>
-            <a:ext cx="3200400" cy="73152"/>
+            <a:off x="4495190" y="1828800"/>
+            <a:ext cx="3200400" cy="64008"/>
           </a:xfrm>
           <a:prstGeom prst="rect">
             <a:avLst/>
@@ -4672,8 +5145,8 @@
         </p:nvSpPr>
         <p:spPr>
           <a:xfrm>
-            <a:off x="4709160" y="2331720"/>
-            <a:ext cx="2743200" cy="3291840"/>
+            <a:off x="4751222" y="2084832"/>
+            <a:ext cx="2688336" cy="3566160"/>
           </a:xfrm>
           <a:prstGeom prst="rect">
             <a:avLst/>
@@ -4688,17 +5161,37 @@
           <a:p>
             <a:pPr>
               <a:spcAft>
-                <a:spcPts val="1000"/>
+                <a:spcPts val="800"/>
               </a:spcAft>
-              <a:defRPr sz="1000" b="1">
+              <a:defRPr sz="900" b="1">
                 <a:solidFill>
                   <a:srgbClr val="0D9488"/>
                 </a:solidFill>
-                <a:latin typeface="Arial"/>
-              </a:defRPr>
-            </a:pPr>
-            <a:r>
-              <a:t>02  •  `ingest-slack`</a:t>
+                <a:latin typeface="Calibri"/>
+              </a:defRPr>
+            </a:pPr>
+            <a:r>
+              <a:t>02  ·  INGEST-SLACK</a:t>
+            </a:r>
+          </a:p>
+          <a:p>
+            <a:pPr>
+              <a:spcAft>
+                <a:spcPts val="1200"/>
+              </a:spcAft>
+              <a:defRPr sz="1700" b="1">
+                <a:solidFill>
+                  <a:srgbClr val="0F172A"/>
+                </a:solidFill>
+                <a:latin typeface="Calibri"/>
+              </a:defRPr>
+            </a:pPr>
+            <a:r>
+              <a:t>Realtime</a:t>
+            </a:r>
+            <a:br/>
+            <a:r>
+              <a:t>Webhook</a:t>
             </a:r>
           </a:p>
           <a:p>
@@ -4706,31 +5199,31 @@
               <a:spcAft>
                 <a:spcPts val="1000"/>
               </a:spcAft>
-              <a:defRPr sz="1800" b="1">
-                <a:solidFill>
-                  <a:srgbClr val="0F172A"/>
-                </a:solidFill>
-                <a:latin typeface="Arial"/>
-              </a:defRPr>
-            </a:pPr>
-            <a:r>
-              <a:t>Event Streams</a:t>
+              <a:defRPr sz="700">
+                <a:solidFill>
+                  <a:srgbClr val="DCE3EB"/>
+                </a:solidFill>
+                <a:latin typeface="Calibri"/>
+              </a:defRPr>
+            </a:pPr>
+            <a:r>
+              <a:t>────────────────────────────────</a:t>
             </a:r>
           </a:p>
           <a:p>
             <a:pPr>
               <a:lnSpc>
-                <a:spcPct val="130000"/>
+                <a:spcPct val="135000"/>
               </a:lnSpc>
               <a:defRPr sz="1200">
                 <a:solidFill>
-                  <a:srgbClr val="475569"/>
-                </a:solidFill>
-                <a:latin typeface="Arial"/>
-              </a:defRPr>
-            </a:pPr>
-            <a:r>
-              <a:t>Real-time Slack webhook receiver for channels. Filters telemetry keys, performs security sanitization (scrubbing PII before storage), and matches discussions to file references.</a:t>
+                  <a:srgbClr val="64748B"/>
+                </a:solidFill>
+                <a:latin typeface="Calibri"/>
+              </a:defRPr>
+            </a:pPr>
+            <a:r>
+              <a:t>Receives Slack events in real-time. Runs PII scrubbing, sanitises telemetry values, extracts user-to-file entity mentions, and persists discussion nodes.</a:t>
             </a:r>
           </a:p>
         </p:txBody>
@@ -4743,8 +5236,8 @@
         </p:nvSpPr>
         <p:spPr>
           <a:xfrm>
-            <a:off x="8046720" y="2011680"/>
-            <a:ext cx="3200400" cy="3931920"/>
+            <a:off x="8075980" y="1828800"/>
+            <a:ext cx="3200400" cy="4023360"/>
           </a:xfrm>
           <a:prstGeom prst="rect">
             <a:avLst/>
@@ -4752,9 +5245,9 @@
           <a:solidFill>
             <a:srgbClr val="FFFFFF"/>
           </a:solidFill>
-          <a:ln w="19050">
+          <a:ln w="15240">
             <a:solidFill>
-              <a:srgbClr val="E2E8F0"/>
+              <a:srgbClr val="DCE3EB"/>
             </a:solidFill>
           </a:ln>
         </p:spPr>
@@ -4788,14 +5281,14 @@
         </p:nvSpPr>
         <p:spPr>
           <a:xfrm>
-            <a:off x="8046720" y="2011680"/>
-            <a:ext cx="3200400" cy="73152"/>
+            <a:off x="8075980" y="1828800"/>
+            <a:ext cx="3200400" cy="64008"/>
           </a:xfrm>
           <a:prstGeom prst="rect">
             <a:avLst/>
           </a:prstGeom>
           <a:solidFill>
-            <a:srgbClr val="059669"/>
+            <a:srgbClr val="7C3AED"/>
           </a:solidFill>
           <a:ln>
             <a:noFill/>
@@ -4831,8 +5324,8 @@
         </p:nvSpPr>
         <p:spPr>
           <a:xfrm>
-            <a:off x="8275320" y="2331720"/>
-            <a:ext cx="2743200" cy="3291840"/>
+            <a:off x="8332012" y="2084832"/>
+            <a:ext cx="2688336" cy="3566160"/>
           </a:xfrm>
           <a:prstGeom prst="rect">
             <a:avLst/>
@@ -4847,17 +5340,37 @@
           <a:p>
             <a:pPr>
               <a:spcAft>
-                <a:spcPts val="1000"/>
+                <a:spcPts val="800"/>
               </a:spcAft>
-              <a:defRPr sz="1000" b="1">
-                <a:solidFill>
-                  <a:srgbClr val="059669"/>
-                </a:solidFill>
-                <a:latin typeface="Arial"/>
-              </a:defRPr>
-            </a:pPr>
-            <a:r>
-              <a:t>03  •  `reconstruct`</a:t>
+              <a:defRPr sz="900" b="1">
+                <a:solidFill>
+                  <a:srgbClr val="7C3AED"/>
+                </a:solidFill>
+                <a:latin typeface="Calibri"/>
+              </a:defRPr>
+            </a:pPr>
+            <a:r>
+              <a:t>03  ·  RECONSTRUCT</a:t>
+            </a:r>
+          </a:p>
+          <a:p>
+            <a:pPr>
+              <a:spcAft>
+                <a:spcPts val="1200"/>
+              </a:spcAft>
+              <a:defRPr sz="1700" b="1">
+                <a:solidFill>
+                  <a:srgbClr val="0F172A"/>
+                </a:solidFill>
+                <a:latin typeface="Calibri"/>
+              </a:defRPr>
+            </a:pPr>
+            <a:r>
+              <a:t>AI</a:t>
+            </a:r>
+            <a:br/>
+            <a:r>
+              <a:t>Reconstruction</a:t>
             </a:r>
           </a:p>
           <a:p>
@@ -4865,31 +5378,31 @@
               <a:spcAft>
                 <a:spcPts val="1000"/>
               </a:spcAft>
-              <a:defRPr sz="1800" b="1">
-                <a:solidFill>
-                  <a:srgbClr val="0F172A"/>
-                </a:solidFill>
-                <a:latin typeface="Arial"/>
-              </a:defRPr>
-            </a:pPr>
-            <a:r>
-              <a:t>AI Reconstruction</a:t>
+              <a:defRPr sz="700">
+                <a:solidFill>
+                  <a:srgbClr val="DCE3EB"/>
+                </a:solidFill>
+                <a:latin typeface="Calibri"/>
+              </a:defRPr>
+            </a:pPr>
+            <a:r>
+              <a:t>────────────────────────────────</a:t>
             </a:r>
           </a:p>
           <a:p>
             <a:pPr>
               <a:lnSpc>
-                <a:spcPct val="130000"/>
+                <a:spcPct val="135000"/>
               </a:lnSpc>
               <a:defRPr sz="1200">
                 <a:solidFill>
-                  <a:srgbClr val="475569"/>
-                </a:solidFill>
-                <a:latin typeface="Arial"/>
-              </a:defRPr>
-            </a:pPr>
-            <a:r>
-              <a:t>Background worker triggered when incidents open. Queries a 4-hour temporal window around the alert, structures the causal subgraph, and calls LLaMA 3.1 70B via NVIDIA NIM.</a:t>
+                  <a:srgbClr val="64748B"/>
+                </a:solidFill>
+                <a:latin typeface="Calibri"/>
+              </a:defRPr>
+            </a:pPr>
+            <a:r>
+              <a:t>9-stage background worker. Pulls a 4-hour temporal subgraph, compiles diff summaries, and calls NVIDIA NIM (LLaMA 3.1 70B) to generate the causal incident timeline.</a:t>
             </a:r>
           </a:p>
         </p:txBody>
@@ -4908,7 +5421,7 @@
     <p:bg>
       <p:bgPr>
         <a:solidFill>
-          <a:srgbClr val="F8FAFC"/>
+          <a:srgbClr val="FAFBFC"/>
         </a:solidFill>
         <a:effectLst/>
       </p:bgPr>
@@ -4929,7 +5442,7 @@
         <p:spPr>
           <a:xfrm>
             <a:off x="914400" y="457200"/>
-            <a:ext cx="10360152" cy="274320"/>
+            <a:ext cx="10058400" cy="256032"/>
           </a:xfrm>
           <a:prstGeom prst="rect">
             <a:avLst/>
@@ -4943,15 +5456,15 @@
           <a:lstStyle/>
           <a:p>
             <a:pPr>
-              <a:defRPr sz="1000" b="1">
-                <a:solidFill>
-                  <a:srgbClr val="059669"/>
-                </a:solidFill>
-                <a:latin typeface="Arial"/>
-              </a:defRPr>
-            </a:pPr>
-            <a:r>
-              <a:t>04. MOBILE &amp; SPEECH ENGINE</a:t>
+              <a:defRPr sz="950" b="1">
+                <a:solidFill>
+                  <a:srgbClr val="0D9488"/>
+                </a:solidFill>
+                <a:latin typeface="Calibri"/>
+              </a:defRPr>
+            </a:pPr>
+            <a:r>
+              <a:t>04  ·  MOBILE &amp; VOICE ENGINE</a:t>
             </a:r>
           </a:p>
         </p:txBody>
@@ -4964,8 +5477,8 @@
         </p:nvSpPr>
         <p:spPr>
           <a:xfrm>
-            <a:off x="914400" y="731520"/>
-            <a:ext cx="10360152" cy="640080"/>
+            <a:off x="914400" y="749808"/>
+            <a:ext cx="10058400" cy="822960"/>
           </a:xfrm>
           <a:prstGeom prst="rect">
             <a:avLst/>
@@ -4979,15 +5492,15 @@
           <a:lstStyle/>
           <a:p>
             <a:pPr>
-              <a:defRPr sz="3200" b="1">
+              <a:defRPr sz="3000" b="1">
                 <a:solidFill>
                   <a:srgbClr val="0F172A"/>
                 </a:solidFill>
-                <a:latin typeface="Arial"/>
-              </a:defRPr>
-            </a:pPr>
-            <a:r>
-              <a:t>Expo Native App &amp; Sarvam AI Voice Triage</a:t>
+                <a:latin typeface="Calibri"/>
+              </a:defRPr>
+            </a:pPr>
+            <a:r>
+              <a:t>Expo + Sarvam AI — Hands-free on-call triage.</a:t>
             </a:r>
           </a:p>
         </p:txBody>
@@ -5000,14 +5513,14 @@
         </p:nvSpPr>
         <p:spPr>
           <a:xfrm>
-            <a:off x="914400" y="1463040"/>
-            <a:ext cx="10362895" cy="19050"/>
+            <a:off x="914400" y="1627632"/>
+            <a:ext cx="10362895" cy="15240"/>
           </a:xfrm>
           <a:prstGeom prst="rect">
             <a:avLst/>
           </a:prstGeom>
           <a:solidFill>
-            <a:srgbClr val="E2E8F0"/>
+            <a:srgbClr val="CBD5E1"/>
           </a:solidFill>
           <a:ln>
             <a:noFill/>
@@ -5043,8 +5556,8 @@
         </p:nvSpPr>
         <p:spPr>
           <a:xfrm>
-            <a:off x="914400" y="2011680"/>
-            <a:ext cx="6217920" cy="4114800"/>
+            <a:off x="914400" y="1828800"/>
+            <a:ext cx="6400800" cy="502920"/>
           </a:xfrm>
           <a:prstGeom prst="rect">
             <a:avLst/>
@@ -5058,102 +5571,146 @@
           <a:lstStyle/>
           <a:p>
             <a:pPr>
+              <a:defRPr sz="1350">
+                <a:solidFill>
+                  <a:srgbClr val="64748B"/>
+                </a:solidFill>
+                <a:latin typeface="Calibri"/>
+              </a:defRPr>
+            </a:pPr>
+            <a:r>
+              <a:t>Incidents happen at 3 AM away from a laptop. Voice + mobile brings the Black Box to the engineer.</a:t>
+            </a:r>
+          </a:p>
+        </p:txBody>
+      </p:sp>
+      <p:sp>
+        <p:nvSpPr>
+          <p:cNvPr id="6" name="TextBox 5"/>
+          <p:cNvSpPr txBox="1"/>
+          <p:nvPr/>
+        </p:nvSpPr>
+        <p:spPr>
+          <a:xfrm>
+            <a:off x="914400" y="2514600"/>
+            <a:ext cx="6309360" cy="3383280"/>
+          </a:xfrm>
+          <a:prstGeom prst="rect">
+            <a:avLst/>
+          </a:prstGeom>
+          <a:noFill/>
+        </p:spPr>
+        <p:txBody>
+          <a:bodyPr wrap="square" lIns="0" rIns="0" tIns="0" bIns="0">
+            <a:spAutoFit/>
+          </a:bodyPr>
+          <a:lstStyle/>
+          <a:p>
+            <a:pPr>
               <a:lnSpc>
-                <a:spcPct val="140000"/>
-              </a:lnSpc>
-              <a:spcAft>
-                <a:spcPts val="2000"/>
-              </a:spcAft>
-              <a:defRPr sz="1400">
-                <a:solidFill>
-                  <a:srgbClr val="475569"/>
-                </a:solidFill>
-                <a:latin typeface="Arial"/>
-              </a:defRPr>
-            </a:pPr>
-            <a:r>
-              <a:t>Incidents occur when developers are away from keyboard. Our Expo native client and Sarvam voice pipeline enable hands-free triage from anywhere.</a:t>
-            </a:r>
-          </a:p>
-          <a:p>
-            <a:pPr>
-              <a:lnSpc>
-                <a:spcPct val="120000"/>
+                <a:spcPct val="125000"/>
               </a:lnSpc>
               <a:spcBef>
-                <a:spcPts val="1000"/>
+                <a:spcPts val="900"/>
               </a:spcBef>
-              <a:defRPr sz="1300">
-                <a:solidFill>
-                  <a:srgbClr val="0F172A"/>
-                </a:solidFill>
-                <a:latin typeface="Arial"/>
-              </a:defRPr>
-            </a:pPr>
-            <a:r>
-              <a:t>✔  Expo Push Alerts: Real-time on-call mobile push alerts featuring initial AI causal summaries.</a:t>
+            </a:pPr>
+            <a:r>
+              <a:rPr sz="1300" b="1">
+                <a:solidFill>
+                  <a:srgbClr val="0D9488"/>
+                </a:solidFill>
+                <a:latin typeface="Calibri"/>
+              </a:rPr>
+              <a:t>◎  </a:t>
+            </a:r>
+            <a:r>
+              <a:rPr sz="1300">
+                <a:solidFill>
+                  <a:srgbClr val="334155"/>
+                </a:solidFill>
+                <a:latin typeface="Calibri"/>
+              </a:rPr>
+              <a:t>Expo Push Alerts — real-time push notifications to iOS/Android with a first-pass AI incident summary.</a:t>
             </a:r>
           </a:p>
           <a:p>
             <a:pPr>
               <a:lnSpc>
-                <a:spcPct val="120000"/>
+                <a:spcPct val="125000"/>
               </a:lnSpc>
               <a:spcBef>
-                <a:spcPts val="1000"/>
+                <a:spcPts val="900"/>
               </a:spcBef>
-              <a:defRPr sz="1300">
-                <a:solidFill>
-                  <a:srgbClr val="0F172A"/>
-                </a:solidFill>
-                <a:latin typeface="Arial"/>
-              </a:defRPr>
-            </a:pPr>
-            <a:r>
-              <a:t>✔  Sarvam Speech-to-Text: On-call engineers can ask questions via voice ('What broke on payment service last night?') to query the graph.</a:t>
+            </a:pPr>
+            <a:r>
+              <a:rPr sz="1300" b="1">
+                <a:solidFill>
+                  <a:srgbClr val="0D9488"/>
+                </a:solidFill>
+                <a:latin typeface="Calibri"/>
+              </a:rPr>
+              <a:t>◎  </a:t>
+            </a:r>
+            <a:r>
+              <a:rPr sz="1300">
+                <a:solidFill>
+                  <a:srgbClr val="334155"/>
+                </a:solidFill>
+                <a:latin typeface="Calibri"/>
+              </a:rPr>
+              <a:t>Sarvam STT — engineers speak a query ('What broke on payment service at 2 AM?'); speech converts to a structured Neo4j graph query.</a:t>
             </a:r>
           </a:p>
           <a:p>
             <a:pPr>
               <a:lnSpc>
-                <a:spcPct val="120000"/>
+                <a:spcPct val="125000"/>
               </a:lnSpc>
               <a:spcBef>
-                <a:spcPts val="1000"/>
+                <a:spcPts val="900"/>
               </a:spcBef>
-              <a:defRPr sz="1300">
-                <a:solidFill>
-                  <a:srgbClr val="0F172A"/>
-                </a:solidFill>
-                <a:latin typeface="Arial"/>
-              </a:defRPr>
-            </a:pPr>
-            <a:r>
-              <a:t>✔  Sarvam Text-to-Speech: Synthesizes voice briefings of incident timelines in English and Hindi directly on the mobile app.</a:t>
-            </a:r>
-          </a:p>
-        </p:txBody>
-      </p:sp>
-      <p:sp>
-        <p:nvSpPr>
-          <p:cNvPr id="6" name="Rectangle 5"/>
+            </a:pPr>
+            <a:r>
+              <a:rPr sz="1300" b="1">
+                <a:solidFill>
+                  <a:srgbClr val="0D9488"/>
+                </a:solidFill>
+                <a:latin typeface="Calibri"/>
+              </a:rPr>
+              <a:t>◎  </a:t>
+            </a:r>
+            <a:r>
+              <a:rPr sz="1300">
+                <a:solidFill>
+                  <a:srgbClr val="334155"/>
+                </a:solidFill>
+                <a:latin typeface="Calibri"/>
+              </a:rPr>
+              <a:t>Sarvam TTS — the AI-synthesized incident timeline is read back as multilingual audio (English + Hindi) — no screen required.</a:t>
+            </a:r>
+          </a:p>
+        </p:txBody>
+      </p:sp>
+      <p:sp>
+        <p:nvSpPr>
+          <p:cNvPr id="7" name="Rectangle 6"/>
           <p:cNvSpPr/>
           <p:nvPr/>
         </p:nvSpPr>
         <p:spPr>
           <a:xfrm>
-            <a:off x="7589520" y="2011680"/>
-            <a:ext cx="3657600" cy="3840480"/>
+            <a:off x="7589520" y="1828800"/>
+            <a:ext cx="3657600" cy="4114800"/>
           </a:xfrm>
           <a:prstGeom prst="rect">
             <a:avLst/>
           </a:prstGeom>
           <a:solidFill>
-            <a:srgbClr val="F1F5F9"/>
+            <a:srgbClr val="FFFFFF"/>
           </a:solidFill>
-          <a:ln w="19050">
+          <a:ln w="15240">
             <a:solidFill>
-              <a:srgbClr val="E2E8F0"/>
+              <a:srgbClr val="DCE3EB"/>
             </a:solidFill>
           </a:ln>
         </p:spPr>
@@ -5181,14 +5738,14 @@
       </p:sp>
       <p:sp>
         <p:nvSpPr>
-          <p:cNvPr id="7" name="Rectangle 6"/>
+          <p:cNvPr id="8" name="Rectangle 7"/>
           <p:cNvSpPr/>
           <p:nvPr/>
         </p:nvSpPr>
         <p:spPr>
           <a:xfrm>
-            <a:off x="7589520" y="2011680"/>
-            <a:ext cx="3657600" cy="73152"/>
+            <a:off x="7589520" y="1828800"/>
+            <a:ext cx="3657600" cy="64008"/>
           </a:xfrm>
           <a:prstGeom prst="rect">
             <a:avLst/>
@@ -5224,14 +5781,57 @@
       </p:sp>
       <p:sp>
         <p:nvSpPr>
-          <p:cNvPr id="8" name="TextBox 7"/>
+          <p:cNvPr id="9" name="Rectangle 8"/>
+          <p:cNvSpPr/>
+          <p:nvPr/>
+        </p:nvSpPr>
+        <p:spPr>
+          <a:xfrm>
+            <a:off x="7589520" y="1892807"/>
+            <a:ext cx="3657600" cy="4050791"/>
+          </a:xfrm>
+          <a:prstGeom prst="rect">
+            <a:avLst/>
+          </a:prstGeom>
+          <a:solidFill>
+            <a:srgbClr val="F1F5F9"/>
+          </a:solidFill>
+          <a:ln>
+            <a:noFill/>
+          </a:ln>
+        </p:spPr>
+        <p:style>
+          <a:lnRef idx="1">
+            <a:schemeClr val="accent1"/>
+          </a:lnRef>
+          <a:fillRef idx="3">
+            <a:schemeClr val="accent1"/>
+          </a:fillRef>
+          <a:effectRef idx="2">
+            <a:schemeClr val="accent1"/>
+          </a:effectRef>
+          <a:fontRef idx="minor">
+            <a:schemeClr val="lt1"/>
+          </a:fontRef>
+        </p:style>
+        <p:txBody>
+          <a:bodyPr rtlCol="0" anchor="ctr"/>
+          <a:lstStyle/>
+          <a:p>
+            <a:pPr algn="ctr"/>
+          </a:p>
+        </p:txBody>
+      </p:sp>
+      <p:sp>
+        <p:nvSpPr>
+          <p:cNvPr id="10" name="TextBox 9"/>
           <p:cNvSpPr txBox="1"/>
           <p:nvPr/>
         </p:nvSpPr>
         <p:spPr>
           <a:xfrm>
-            <a:off x="7955279" y="2286000"/>
-            <a:ext cx="2926080" cy="3291840"/>
+            <a:off x="7818120" y="2057400"/>
+            <a:ext cx="3246120" cy="3657600"/>
           </a:xfrm>
           <a:prstGeom prst="rect">
             <a:avLst/>
@@ -5246,113 +5846,167 @@
           <a:p>
             <a:pPr>
               <a:spcAft>
-                <a:spcPts val="2000"/>
+                <a:spcPts val="1400"/>
               </a:spcAft>
-              <a:defRPr sz="1100" b="1">
+              <a:defRPr sz="900" b="1">
                 <a:solidFill>
                   <a:srgbClr val="0D9488"/>
                 </a:solidFill>
-                <a:latin typeface="Arial"/>
-              </a:defRPr>
-            </a:pPr>
-            <a:r>
-              <a:t>VOICE INTELLIGENCE ROUTING</a:t>
+                <a:latin typeface="Calibri"/>
+              </a:defRPr>
+            </a:pPr>
+            <a:r>
+              <a:t>VOICE CALL ROUTING</a:t>
             </a:r>
           </a:p>
           <a:p>
             <a:pPr>
               <a:spcBef>
-                <a:spcPts val="600"/>
+                <a:spcPts val="700"/>
               </a:spcBef>
-              <a:defRPr sz="1050" b="1">
+            </a:pPr>
+            <a:r>
+              <a:rPr sz="1100" b="1">
+                <a:solidFill>
+                  <a:srgbClr val="0D9488"/>
+                </a:solidFill>
+                <a:latin typeface="Calibri"/>
+              </a:rPr>
+              <a:t>1 ▸  </a:t>
+            </a:r>
+            <a:r>
+              <a:rPr sz="1100">
                 <a:solidFill>
                   <a:srgbClr val="0F172A"/>
                 </a:solidFill>
-                <a:latin typeface="Courier New"/>
-              </a:defRPr>
-            </a:pPr>
-            <a:r>
-              <a:t>1. Capture User Audio (Expo Client API)</a:t>
+                <a:latin typeface="Calibri"/>
+              </a:rPr>
+              <a:t>Expo captures voice audio</a:t>
             </a:r>
           </a:p>
           <a:p>
             <a:pPr>
               <a:spcBef>
-                <a:spcPts val="600"/>
+                <a:spcPts val="700"/>
               </a:spcBef>
-              <a:defRPr sz="1050" b="1">
+            </a:pPr>
+            <a:r>
+              <a:rPr sz="1100" b="1">
+                <a:solidFill>
+                  <a:srgbClr val="0D9488"/>
+                </a:solidFill>
+                <a:latin typeface="Calibri"/>
+              </a:rPr>
+              <a:t>2 ▸  </a:t>
+            </a:r>
+            <a:r>
+              <a:rPr sz="1100">
                 <a:solidFill>
                   <a:srgbClr val="0F172A"/>
                 </a:solidFill>
-                <a:latin typeface="Courier New"/>
-              </a:defRPr>
-            </a:pPr>
-            <a:r>
-              <a:t>2. Sarvam STT Engine (Audio to Query Text)</a:t>
+                <a:latin typeface="Calibri"/>
+              </a:rPr>
+              <a:t>Sarvam STT → query string</a:t>
             </a:r>
           </a:p>
           <a:p>
             <a:pPr>
               <a:spcBef>
-                <a:spcPts val="600"/>
+                <a:spcPts val="700"/>
               </a:spcBef>
-              <a:defRPr sz="1050" b="1">
+            </a:pPr>
+            <a:r>
+              <a:rPr sz="1100" b="1">
+                <a:solidFill>
+                  <a:srgbClr val="0D9488"/>
+                </a:solidFill>
+                <a:latin typeface="Calibri"/>
+              </a:rPr>
+              <a:t>3 ▸  </a:t>
+            </a:r>
+            <a:r>
+              <a:rPr sz="1100">
                 <a:solidFill>
                   <a:srgbClr val="0F172A"/>
                 </a:solidFill>
-                <a:latin typeface="Courier New"/>
-              </a:defRPr>
-            </a:pPr>
-            <a:r>
-              <a:t>3. Spring Boot Service (Query parser routing)</a:t>
+                <a:latin typeface="Calibri"/>
+              </a:rPr>
+              <a:t>Spring Boot parses intent</a:t>
             </a:r>
           </a:p>
           <a:p>
             <a:pPr>
               <a:spcBef>
-                <a:spcPts val="600"/>
+                <a:spcPts val="700"/>
               </a:spcBef>
-              <a:defRPr sz="1050" b="1">
+            </a:pPr>
+            <a:r>
+              <a:rPr sz="1100" b="1">
+                <a:solidFill>
+                  <a:srgbClr val="0D9488"/>
+                </a:solidFill>
+                <a:latin typeface="Calibri"/>
+              </a:rPr>
+              <a:t>4 ▸  </a:t>
+            </a:r>
+            <a:r>
+              <a:rPr sz="1100">
                 <a:solidFill>
                   <a:srgbClr val="0F172A"/>
                 </a:solidFill>
-                <a:latin typeface="Courier New"/>
-              </a:defRPr>
-            </a:pPr>
-            <a:r>
-              <a:t>4. Neo4j Traversal (Cypher context extraction)</a:t>
+                <a:latin typeface="Calibri"/>
+              </a:rPr>
+              <a:t>Neo4j Cypher traversal</a:t>
             </a:r>
           </a:p>
           <a:p>
             <a:pPr>
               <a:spcBef>
-                <a:spcPts val="600"/>
+                <a:spcPts val="700"/>
               </a:spcBef>
-              <a:defRPr sz="1050" b="1">
+            </a:pPr>
+            <a:r>
+              <a:rPr sz="1100" b="1">
+                <a:solidFill>
+                  <a:srgbClr val="0D9488"/>
+                </a:solidFill>
+                <a:latin typeface="Calibri"/>
+              </a:rPr>
+              <a:t>5 ▸  </a:t>
+            </a:r>
+            <a:r>
+              <a:rPr sz="1100">
                 <a:solidFill>
                   <a:srgbClr val="0F172A"/>
                 </a:solidFill>
-                <a:latin typeface="Courier New"/>
-              </a:defRPr>
-            </a:pPr>
-            <a:r>
-              <a:t>5. NVIDIA NIM LLM (Synthesizes structural brief)</a:t>
+                <a:latin typeface="Calibri"/>
+              </a:rPr>
+              <a:t>NVIDIA NIM synthesises brief</a:t>
             </a:r>
           </a:p>
           <a:p>
             <a:pPr>
               <a:spcBef>
-                <a:spcPts val="600"/>
+                <a:spcPts val="700"/>
               </a:spcBef>
-              <a:defRPr sz="1050" b="1">
+            </a:pPr>
+            <a:r>
+              <a:rPr sz="1100" b="1">
+                <a:solidFill>
+                  <a:srgbClr val="0D9488"/>
+                </a:solidFill>
+                <a:latin typeface="Calibri"/>
+              </a:rPr>
+              <a:t>6 ▸  </a:t>
+            </a:r>
+            <a:r>
+              <a:rPr sz="1100">
                 <a:solidFill>
                   <a:srgbClr val="0F172A"/>
                 </a:solidFill>
-                <a:latin typeface="Courier New"/>
-              </a:defRPr>
-            </a:pPr>
-            <a:r>
-              <a:t>6. Sarvam TTS Engine (Audio briefing returned)</a:t>
+                <a:latin typeface="Calibri"/>
+              </a:rPr>
+              <a:t>Sarvam TTS → audio reply</a:t>
             </a:r>
           </a:p>
         </p:txBody>
@@ -5371,7 +6025,7 @@
     <p:bg>
       <p:bgPr>
         <a:solidFill>
-          <a:srgbClr val="F8FAFC"/>
+          <a:srgbClr val="FAFBFC"/>
         </a:solidFill>
         <a:effectLst/>
       </p:bgPr>
@@ -5392,7 +6046,7 @@
         <p:spPr>
           <a:xfrm>
             <a:off x="914400" y="457200"/>
-            <a:ext cx="10360152" cy="274320"/>
+            <a:ext cx="10058400" cy="256032"/>
           </a:xfrm>
           <a:prstGeom prst="rect">
             <a:avLst/>
@@ -5406,15 +6060,15 @@
           <a:lstStyle/>
           <a:p>
             <a:pPr>
-              <a:defRPr sz="1000" b="1">
+              <a:defRPr sz="950" b="1">
                 <a:solidFill>
                   <a:srgbClr val="059669"/>
                 </a:solidFill>
-                <a:latin typeface="Arial"/>
-              </a:defRPr>
-            </a:pPr>
-            <a:r>
-              <a:t>05. SYSTEM SPECIFICATION</a:t>
+                <a:latin typeface="Calibri"/>
+              </a:defRPr>
+            </a:pPr>
+            <a:r>
+              <a:t>05  ·  SYSTEM SPECIFICATION</a:t>
             </a:r>
           </a:p>
         </p:txBody>
@@ -5427,8 +6081,8 @@
         </p:nvSpPr>
         <p:spPr>
           <a:xfrm>
-            <a:off x="914400" y="731520"/>
-            <a:ext cx="10360152" cy="640080"/>
+            <a:off x="914400" y="749808"/>
+            <a:ext cx="10058400" cy="822960"/>
           </a:xfrm>
           <a:prstGeom prst="rect">
             <a:avLst/>
@@ -5442,15 +6096,15 @@
           <a:lstStyle/>
           <a:p>
             <a:pPr>
-              <a:defRPr sz="3200" b="1">
+              <a:defRPr sz="3000" b="1">
                 <a:solidFill>
                   <a:srgbClr val="0F172A"/>
                 </a:solidFill>
-                <a:latin typeface="Arial"/>
-              </a:defRPr>
-            </a:pPr>
-            <a:r>
-              <a:t>Under the Hood: Technical Ecosystem</a:t>
+                <a:latin typeface="Calibri"/>
+              </a:defRPr>
+            </a:pPr>
+            <a:r>
+              <a:t>Full-stack specification.</a:t>
             </a:r>
           </a:p>
         </p:txBody>
@@ -5463,14 +6117,14 @@
         </p:nvSpPr>
         <p:spPr>
           <a:xfrm>
-            <a:off x="914400" y="1463040"/>
-            <a:ext cx="10362895" cy="19050"/>
+            <a:off x="914400" y="1627632"/>
+            <a:ext cx="10362895" cy="15240"/>
           </a:xfrm>
           <a:prstGeom prst="rect">
             <a:avLst/>
           </a:prstGeom>
           <a:solidFill>
-            <a:srgbClr val="E2E8F0"/>
+            <a:srgbClr val="CBD5E1"/>
           </a:solidFill>
           <a:ln>
             <a:noFill/>
@@ -5506,8 +6160,8 @@
         </p:nvSpPr>
         <p:spPr>
           <a:xfrm>
-            <a:off x="914400" y="2011680"/>
-            <a:ext cx="3200400" cy="3931920"/>
+            <a:off x="914400" y="1828800"/>
+            <a:ext cx="3200400" cy="4023360"/>
           </a:xfrm>
           <a:prstGeom prst="rect">
             <a:avLst/>
@@ -5515,9 +6169,9 @@
           <a:solidFill>
             <a:srgbClr val="FFFFFF"/>
           </a:solidFill>
-          <a:ln w="19050">
+          <a:ln w="15240">
             <a:solidFill>
-              <a:srgbClr val="E2E8F0"/>
+              <a:srgbClr val="DCE3EB"/>
             </a:solidFill>
           </a:ln>
         </p:spPr>
@@ -5551,8 +6205,8 @@
         </p:nvSpPr>
         <p:spPr>
           <a:xfrm>
-            <a:off x="914400" y="2011680"/>
-            <a:ext cx="3200400" cy="73152"/>
+            <a:off x="914400" y="1828800"/>
+            <a:ext cx="3200400" cy="64008"/>
           </a:xfrm>
           <a:prstGeom prst="rect">
             <a:avLst/>
@@ -5594,8 +6248,8 @@
         </p:nvSpPr>
         <p:spPr>
           <a:xfrm>
-            <a:off x="1143000" y="2331720"/>
-            <a:ext cx="2743200" cy="3291840"/>
+            <a:off x="1170432" y="2084832"/>
+            <a:ext cx="2688336" cy="3566160"/>
           </a:xfrm>
           <a:prstGeom prst="rect">
             <a:avLst/>
@@ -5610,109 +6264,85 @@
           <a:p>
             <a:pPr>
               <a:spcAft>
+                <a:spcPts val="800"/>
+              </a:spcAft>
+              <a:defRPr sz="900" b="1">
+                <a:solidFill>
+                  <a:srgbClr val="059669"/>
+                </a:solidFill>
+                <a:latin typeface="Calibri"/>
+              </a:defRPr>
+            </a:pPr>
+            <a:r>
+              <a:t>CORE BACKEND</a:t>
+            </a:r>
+          </a:p>
+          <a:p>
+            <a:pPr>
+              <a:spcAft>
+                <a:spcPts val="1200"/>
+              </a:spcAft>
+              <a:defRPr sz="1700" b="1">
+                <a:solidFill>
+                  <a:srgbClr val="0F172A"/>
+                </a:solidFill>
+                <a:latin typeface="Calibri"/>
+              </a:defRPr>
+            </a:pPr>
+            <a:r>
+              <a:t>Spring Boot</a:t>
+            </a:r>
+            <a:br/>
+            <a:r>
+              <a:t>API Server</a:t>
+            </a:r>
+          </a:p>
+          <a:p>
+            <a:pPr>
+              <a:spcAft>
                 <a:spcPts val="1000"/>
               </a:spcAft>
-              <a:defRPr sz="1000" b="1">
-                <a:solidFill>
-                  <a:srgbClr val="059669"/>
-                </a:solidFill>
-                <a:latin typeface="Arial"/>
-              </a:defRPr>
-            </a:pPr>
-            <a:r>
-              <a:t>CORE BACKEND</a:t>
-            </a:r>
-          </a:p>
-          <a:p>
-            <a:pPr>
-              <a:spcAft>
-                <a:spcPts val="1500"/>
-              </a:spcAft>
-              <a:defRPr sz="1800" b="1">
-                <a:solidFill>
-                  <a:srgbClr val="0F172A"/>
-                </a:solidFill>
-                <a:latin typeface="Arial"/>
-              </a:defRPr>
-            </a:pPr>
-            <a:r>
-              <a:t>Spring Boot API</a:t>
+              <a:defRPr sz="700">
+                <a:solidFill>
+                  <a:srgbClr val="DCE3EB"/>
+                </a:solidFill>
+                <a:latin typeface="Calibri"/>
+              </a:defRPr>
+            </a:pPr>
+            <a:r>
+              <a:t>────────────────────────────────</a:t>
             </a:r>
           </a:p>
           <a:p>
             <a:pPr>
               <a:lnSpc>
-                <a:spcPct val="120000"/>
+                <a:spcPct val="135000"/>
               </a:lnSpc>
-              <a:spcBef>
-                <a:spcPts val="500"/>
-              </a:spcBef>
               <a:defRPr sz="1200">
                 <a:solidFill>
-                  <a:srgbClr val="475569"/>
-                </a:solidFill>
-                <a:latin typeface="Arial"/>
-              </a:defRPr>
-            </a:pPr>
-            <a:r>
-              <a:t>•  Java 17 runtime environment</a:t>
-            </a:r>
-          </a:p>
-          <a:p>
-            <a:pPr>
-              <a:lnSpc>
-                <a:spcPct val="120000"/>
-              </a:lnSpc>
-              <a:spcBef>
-                <a:spcPts val="500"/>
-              </a:spcBef>
-              <a:defRPr sz="1200">
-                <a:solidFill>
-                  <a:srgbClr val="475569"/>
-                </a:solidFill>
-                <a:latin typeface="Arial"/>
-              </a:defRPr>
-            </a:pPr>
-            <a:r>
-              <a:t>•  Spring WebFlux (Reactive client routing)</a:t>
-            </a:r>
-          </a:p>
-          <a:p>
-            <a:pPr>
-              <a:lnSpc>
-                <a:spcPct val="120000"/>
-              </a:lnSpc>
-              <a:spcBef>
-                <a:spcPts val="500"/>
-              </a:spcBef>
-              <a:defRPr sz="1200">
-                <a:solidFill>
-                  <a:srgbClr val="475569"/>
-                </a:solidFill>
-                <a:latin typeface="Arial"/>
-              </a:defRPr>
-            </a:pPr>
-            <a:r>
-              <a:t>•  Spring Data Neo4j SDN repository layer</a:t>
-            </a:r>
-          </a:p>
-          <a:p>
-            <a:pPr>
-              <a:lnSpc>
-                <a:spcPct val="120000"/>
-              </a:lnSpc>
-              <a:spcBef>
-                <a:spcPts val="500"/>
-              </a:spcBef>
-              <a:defRPr sz="1200">
-                <a:solidFill>
-                  <a:srgbClr val="475569"/>
-                </a:solidFill>
-                <a:latin typeface="Arial"/>
-              </a:defRPr>
-            </a:pPr>
-            <a:r>
-              <a:t>•  WebSocket servers for real-time dashboard</a:t>
+                  <a:srgbClr val="64748B"/>
+                </a:solidFill>
+                <a:latin typeface="Calibri"/>
+              </a:defRPr>
+            </a:pPr>
+            <a:r>
+              <a:t>Java 17  ·  Spring Boot 3.3</a:t>
+            </a:r>
+            <a:br/>
+            <a:r>
+              <a:t>Spring WebFlux (reactive I/O)</a:t>
+            </a:r>
+            <a:br/>
+            <a:r>
+              <a:t>Spring Data Neo4j (SDN)</a:t>
+            </a:r>
+            <a:br/>
+            <a:r>
+              <a:t>WebSocket for live streaming</a:t>
+            </a:r>
+            <a:br/>
+            <a:r>
+              <a:t>Hosted on Render cloud</a:t>
             </a:r>
           </a:p>
         </p:txBody>
@@ -5725,8 +6355,8 @@
         </p:nvSpPr>
         <p:spPr>
           <a:xfrm>
-            <a:off x="4480560" y="2011680"/>
-            <a:ext cx="3200400" cy="3931920"/>
+            <a:off x="4495190" y="1828800"/>
+            <a:ext cx="3200400" cy="4023360"/>
           </a:xfrm>
           <a:prstGeom prst="rect">
             <a:avLst/>
@@ -5734,9 +6364,9 @@
           <a:solidFill>
             <a:srgbClr val="FFFFFF"/>
           </a:solidFill>
-          <a:ln w="19050">
+          <a:ln w="15240">
             <a:solidFill>
-              <a:srgbClr val="E2E8F0"/>
+              <a:srgbClr val="DCE3EB"/>
             </a:solidFill>
           </a:ln>
         </p:spPr>
@@ -5770,8 +6400,8 @@
         </p:nvSpPr>
         <p:spPr>
           <a:xfrm>
-            <a:off x="4480560" y="2011680"/>
-            <a:ext cx="3200400" cy="73152"/>
+            <a:off x="4495190" y="1828800"/>
+            <a:ext cx="3200400" cy="64008"/>
           </a:xfrm>
           <a:prstGeom prst="rect">
             <a:avLst/>
@@ -5813,8 +6443,8 @@
         </p:nvSpPr>
         <p:spPr>
           <a:xfrm>
-            <a:off x="4709160" y="2331720"/>
-            <a:ext cx="2743200" cy="3291840"/>
+            <a:off x="4751222" y="2084832"/>
+            <a:ext cx="2688336" cy="3566160"/>
           </a:xfrm>
           <a:prstGeom prst="rect">
             <a:avLst/>
@@ -5829,109 +6459,81 @@
           <a:p>
             <a:pPr>
               <a:spcAft>
+                <a:spcPts val="800"/>
+              </a:spcAft>
+              <a:defRPr sz="900" b="1">
+                <a:solidFill>
+                  <a:srgbClr val="0D9488"/>
+                </a:solidFill>
+                <a:latin typeface="Calibri"/>
+              </a:defRPr>
+            </a:pPr>
+            <a:r>
+              <a:t>GRAPH &amp; INTELLIGENCE</a:t>
+            </a:r>
+          </a:p>
+          <a:p>
+            <a:pPr>
+              <a:spcAft>
+                <a:spcPts val="1200"/>
+              </a:spcAft>
+              <a:defRPr sz="1700" b="1">
+                <a:solidFill>
+                  <a:srgbClr val="0F172A"/>
+                </a:solidFill>
+                <a:latin typeface="Calibri"/>
+              </a:defRPr>
+            </a:pPr>
+            <a:r>
+              <a:t>Neo4j AuraDB</a:t>
+            </a:r>
+            <a:br/>
+            <a:r>
+              <a:t>+ NVIDIA NIM</a:t>
+            </a:r>
+          </a:p>
+          <a:p>
+            <a:pPr>
+              <a:spcAft>
                 <a:spcPts val="1000"/>
               </a:spcAft>
-              <a:defRPr sz="1000" b="1">
-                <a:solidFill>
-                  <a:srgbClr val="0D9488"/>
-                </a:solidFill>
-                <a:latin typeface="Arial"/>
-              </a:defRPr>
-            </a:pPr>
-            <a:r>
-              <a:t>DATABASE &amp; COGNITIVE</a:t>
-            </a:r>
-          </a:p>
-          <a:p>
-            <a:pPr>
-              <a:spcAft>
-                <a:spcPts val="1500"/>
-              </a:spcAft>
-              <a:defRPr sz="1800" b="1">
-                <a:solidFill>
-                  <a:srgbClr val="0F172A"/>
-                </a:solidFill>
-                <a:latin typeface="Arial"/>
-              </a:defRPr>
-            </a:pPr>
-            <a:r>
-              <a:t>Neo4j &amp; NVIDIA</a:t>
+              <a:defRPr sz="700">
+                <a:solidFill>
+                  <a:srgbClr val="DCE3EB"/>
+                </a:solidFill>
+                <a:latin typeface="Calibri"/>
+              </a:defRPr>
+            </a:pPr>
+            <a:r>
+              <a:t>────────────────────────────────</a:t>
             </a:r>
           </a:p>
           <a:p>
             <a:pPr>
               <a:lnSpc>
-                <a:spcPct val="120000"/>
+                <a:spcPct val="135000"/>
               </a:lnSpc>
-              <a:spcBef>
-                <a:spcPts val="500"/>
-              </a:spcBef>
               <a:defRPr sz="1200">
                 <a:solidFill>
-                  <a:srgbClr val="475569"/>
-                </a:solidFill>
-                <a:latin typeface="Arial"/>
-              </a:defRPr>
-            </a:pPr>
-            <a:r>
-              <a:t>•  Neo4j AuraDB (Enterprise Graph Platform)</a:t>
-            </a:r>
-          </a:p>
-          <a:p>
-            <a:pPr>
-              <a:lnSpc>
-                <a:spcPct val="120000"/>
-              </a:lnSpc>
-              <a:spcBef>
-                <a:spcPts val="500"/>
-              </a:spcBef>
-              <a:defRPr sz="1200">
-                <a:solidFill>
-                  <a:srgbClr val="475569"/>
-                </a:solidFill>
-                <a:latin typeface="Arial"/>
-              </a:defRPr>
-            </a:pPr>
-            <a:r>
-              <a:t>•  Index-Free Adjacency edge performance</a:t>
-            </a:r>
-          </a:p>
-          <a:p>
-            <a:pPr>
-              <a:lnSpc>
-                <a:spcPct val="120000"/>
-              </a:lnSpc>
-              <a:spcBef>
-                <a:spcPts val="500"/>
-              </a:spcBef>
-              <a:defRPr sz="1200">
-                <a:solidFill>
-                  <a:srgbClr val="475569"/>
-                </a:solidFill>
-                <a:latin typeface="Arial"/>
-              </a:defRPr>
-            </a:pPr>
-            <a:r>
-              <a:t>•  LLaMA 3.1 70B via NVIDIA NIM API keys</a:t>
-            </a:r>
-          </a:p>
-          <a:p>
-            <a:pPr>
-              <a:lnSpc>
-                <a:spcPct val="120000"/>
-              </a:lnSpc>
-              <a:spcBef>
-                <a:spcPts val="500"/>
-              </a:spcBef>
-              <a:defRPr sz="1200">
-                <a:solidFill>
-                  <a:srgbClr val="475569"/>
-                </a:solidFill>
-                <a:latin typeface="Arial"/>
-              </a:defRPr>
-            </a:pPr>
-            <a:r>
-              <a:t>•  Data sanitization matching pipelines</a:t>
+                  <a:srgbClr val="64748B"/>
+                </a:solidFill>
+                <a:latin typeface="Calibri"/>
+              </a:defRPr>
+            </a:pPr>
+            <a:r>
+              <a:t>Neo4j AuraDB (enterprise)</a:t>
+            </a:r>
+            <a:br/>
+            <a:r>
+              <a:t>Index-free adjacency traversal</a:t>
+            </a:r>
+            <a:br/>
+            <a:r>
+              <a:t>LLaMA 3.1 70B via NIM API</a:t>
+            </a:r>
+            <a:br/>
+            <a:r>
+              <a:t>PII webhook redaction pipeline</a:t>
             </a:r>
           </a:p>
         </p:txBody>
@@ -5944,8 +6546,8 @@
         </p:nvSpPr>
         <p:spPr>
           <a:xfrm>
-            <a:off x="8046720" y="2011680"/>
-            <a:ext cx="3200400" cy="3931920"/>
+            <a:off x="8075980" y="1828800"/>
+            <a:ext cx="3200400" cy="4023360"/>
           </a:xfrm>
           <a:prstGeom prst="rect">
             <a:avLst/>
@@ -5953,9 +6555,9 @@
           <a:solidFill>
             <a:srgbClr val="FFFFFF"/>
           </a:solidFill>
-          <a:ln w="19050">
+          <a:ln w="15240">
             <a:solidFill>
-              <a:srgbClr val="E2E8F0"/>
+              <a:srgbClr val="DCE3EB"/>
             </a:solidFill>
           </a:ln>
         </p:spPr>
@@ -5989,14 +6591,14 @@
         </p:nvSpPr>
         <p:spPr>
           <a:xfrm>
-            <a:off x="8046720" y="2011680"/>
-            <a:ext cx="3200400" cy="73152"/>
+            <a:off x="8075980" y="1828800"/>
+            <a:ext cx="3200400" cy="64008"/>
           </a:xfrm>
           <a:prstGeom prst="rect">
             <a:avLst/>
           </a:prstGeom>
           <a:solidFill>
-            <a:srgbClr val="059669"/>
+            <a:srgbClr val="7C3AED"/>
           </a:solidFill>
           <a:ln>
             <a:noFill/>
@@ -6032,8 +6634,8 @@
         </p:nvSpPr>
         <p:spPr>
           <a:xfrm>
-            <a:off x="8275320" y="2331720"/>
-            <a:ext cx="2743200" cy="3291840"/>
+            <a:off x="8332012" y="2084832"/>
+            <a:ext cx="2688336" cy="3566160"/>
           </a:xfrm>
           <a:prstGeom prst="rect">
             <a:avLst/>
@@ -6048,109 +6650,81 @@
           <a:p>
             <a:pPr>
               <a:spcAft>
+                <a:spcPts val="800"/>
+              </a:spcAft>
+              <a:defRPr sz="900" b="1">
+                <a:solidFill>
+                  <a:srgbClr val="7C3AED"/>
+                </a:solidFill>
+                <a:latin typeface="Calibri"/>
+              </a:defRPr>
+            </a:pPr>
+            <a:r>
+              <a:t>CLIENT LAYER</a:t>
+            </a:r>
+          </a:p>
+          <a:p>
+            <a:pPr>
+              <a:spcAft>
+                <a:spcPts val="1200"/>
+              </a:spcAft>
+              <a:defRPr sz="1700" b="1">
+                <a:solidFill>
+                  <a:srgbClr val="0F172A"/>
+                </a:solidFill>
+                <a:latin typeface="Calibri"/>
+              </a:defRPr>
+            </a:pPr>
+            <a:r>
+              <a:t>React 19</a:t>
+            </a:r>
+            <a:br/>
+            <a:r>
+              <a:t>+ Expo SDK</a:t>
+            </a:r>
+          </a:p>
+          <a:p>
+            <a:pPr>
+              <a:spcAft>
                 <a:spcPts val="1000"/>
               </a:spcAft>
-              <a:defRPr sz="1000" b="1">
-                <a:solidFill>
-                  <a:srgbClr val="059669"/>
-                </a:solidFill>
-                <a:latin typeface="Arial"/>
-              </a:defRPr>
-            </a:pPr>
-            <a:r>
-              <a:t>CLIENT CLIENTS</a:t>
-            </a:r>
-          </a:p>
-          <a:p>
-            <a:pPr>
-              <a:spcAft>
-                <a:spcPts val="1500"/>
-              </a:spcAft>
-              <a:defRPr sz="1800" b="1">
-                <a:solidFill>
-                  <a:srgbClr val="0F172A"/>
-                </a:solidFill>
-                <a:latin typeface="Arial"/>
-              </a:defRPr>
-            </a:pPr>
-            <a:r>
-              <a:t>React &amp; Expo</a:t>
+              <a:defRPr sz="700">
+                <a:solidFill>
+                  <a:srgbClr val="DCE3EB"/>
+                </a:solidFill>
+                <a:latin typeface="Calibri"/>
+              </a:defRPr>
+            </a:pPr>
+            <a:r>
+              <a:t>────────────────────────────────</a:t>
             </a:r>
           </a:p>
           <a:p>
             <a:pPr>
               <a:lnSpc>
-                <a:spcPct val="120000"/>
+                <a:spcPct val="135000"/>
               </a:lnSpc>
-              <a:spcBef>
-                <a:spcPts val="500"/>
-              </a:spcBef>
               <a:defRPr sz="1200">
                 <a:solidFill>
-                  <a:srgbClr val="475569"/>
-                </a:solidFill>
-                <a:latin typeface="Arial"/>
-              </a:defRPr>
-            </a:pPr>
-            <a:r>
-              <a:t>•  React 19 single-page dashboard app</a:t>
-            </a:r>
-          </a:p>
-          <a:p>
-            <a:pPr>
-              <a:lnSpc>
-                <a:spcPct val="120000"/>
-              </a:lnSpc>
-              <a:spcBef>
-                <a:spcPts val="500"/>
-              </a:spcBef>
-              <a:defRPr sz="1200">
-                <a:solidFill>
-                  <a:srgbClr val="475569"/>
-                </a:solidFill>
-                <a:latin typeface="Arial"/>
-              </a:defRPr>
-            </a:pPr>
-            <a:r>
-              <a:t>•  Tailwind CSS v4 layouts &amp; typography</a:t>
-            </a:r>
-          </a:p>
-          <a:p>
-            <a:pPr>
-              <a:lnSpc>
-                <a:spcPct val="120000"/>
-              </a:lnSpc>
-              <a:spcBef>
-                <a:spcPts val="500"/>
-              </a:spcBef>
-              <a:defRPr sz="1200">
-                <a:solidFill>
-                  <a:srgbClr val="475569"/>
-                </a:solidFill>
-                <a:latin typeface="Arial"/>
-              </a:defRPr>
-            </a:pPr>
-            <a:r>
-              <a:t>•  Sigma.js canvas graph visualizer component</a:t>
-            </a:r>
-          </a:p>
-          <a:p>
-            <a:pPr>
-              <a:lnSpc>
-                <a:spcPct val="120000"/>
-              </a:lnSpc>
-              <a:spcBef>
-                <a:spcPts val="500"/>
-              </a:spcBef>
-              <a:defRPr sz="1200">
-                <a:solidFill>
-                  <a:srgbClr val="475569"/>
-                </a:solidFill>
-                <a:latin typeface="Arial"/>
-              </a:defRPr>
-            </a:pPr>
-            <a:r>
-              <a:t>•  Expo Router file-based mobile routing</a:t>
+                  <a:srgbClr val="64748B"/>
+                </a:solidFill>
+                <a:latin typeface="Calibri"/>
+              </a:defRPr>
+            </a:pPr>
+            <a:r>
+              <a:t>React 19  ·  Vite 8  ·  TypeScript</a:t>
+            </a:r>
+            <a:br/>
+            <a:r>
+              <a:t>Tailwind CSS v4  ·  Sigma.js</a:t>
+            </a:r>
+            <a:br/>
+            <a:r>
+              <a:t>Sarvam AI (STT + TTS)</a:t>
+            </a:r>
+            <a:br/>
+            <a:r>
+              <a:t>Expo Router (iOS + Android)</a:t>
             </a:r>
           </a:p>
         </p:txBody>

</xml_diff>